<commit_message>
Task 11: add visual token-trace slide of real classifier errors
New slide walks through 3 real misclassified sentences token-by-token
(Exp A, threshold 2.0) with running score chips: concessive summing,
double-negation, and a vocab-noise case where "nhàm chán" sits in
pos_vocab. Numbers verified against clf.get_score().
</commit_message>
<xml_diff>
--- a/Task11_Error_Analysis_Presentation_v2.pptx
+++ b/Task11_Error_Analysis_Presentation_v2.pptx
@@ -13,9 +13,10 @@
     <p:sldId id="261" r:id="rId7"/>
     <p:sldId id="262" r:id="rId8"/>
     <p:sldId id="263" r:id="rId9"/>
+    <p:sldId id="264" r:id="rId10"/>
   </p:sldIdLst>
   <p:notesMasterIdLst>
-    <p:notesMasterId r:id="rId10"/>
+    <p:notesMasterId r:id="rId11"/>
   </p:notesMasterIdLst>
   <p:sldSz cx="12192000" cy="6858000"/>
   <p:notesSz cx="6858000" cy="12192000"/>
@@ -1295,7 +1296,7 @@
           <a:p>
             <a:r>
               <a:rPr lang="en-US" dirty="0"/>
-              <a:t>Ba nguyên nhân gốc giải thích cả lỗi trên test thường lẫn câu khó. Negation window và concessive là 2 nhóm lớn nhất.</a:t>
+              <a:t>Trace token-by-token bằng chính classifier (Exp A, threshold 2.0). 3 ví dụ thật khớp clf.get_score.</a:t>
             </a:r>
             <a:endParaRPr lang="en-US" dirty="0"/>
           </a:p>
@@ -1383,7 +1384,7 @@
           <a:p>
             <a:r>
               <a:rPr lang="en-US" dirty="0"/>
-              <a:t>4 đề xuất; nhấn mạnh dùng 2000 câu khó như regression suite mỗi lần sửa classifier.</a:t>
+              <a:t>Ba nguyên nhân gốc giải thích cả lỗi trên test thường lẫn câu khó. Negation window và concessive là 2 nhóm lớn nhất.</a:t>
             </a:r>
             <a:endParaRPr lang="en-US" dirty="0"/>
           </a:p>
@@ -1471,7 +1472,7 @@
           <a:p>
             <a:r>
               <a:rPr lang="en-US" dirty="0"/>
-              <a:t>Chốt: pipeline ổn, stopwords có ích nhưng chưa đủ; nút thắt thực sự là negation + concessive. Bộ câu khó dùng để đo tiến bộ sau khi sửa.</a:t>
+              <a:t>4 đề xuất; nhấn mạnh dùng 2000 câu khó như regression suite mỗi lần sửa classifier.</a:t>
             </a:r>
             <a:endParaRPr lang="en-US" dirty="0"/>
           </a:p>
@@ -1495,6 +1496,94 @@
             <a:fld id="{F7021451-1387-4CA6-816F-3879F97B5CBC}" type="slidenum">
               <a:rPr lang="en-US"/>
               <a:t>8</a:t>
+            </a:fld>
+            <a:endParaRPr lang="en-US"/>
+          </a:p>
+        </p:txBody>
+      </p:sp>
+    </p:spTree>
+    <p:extLst>
+      <p:ext uri="{BB962C8B-B14F-4D97-AF65-F5344CB8AC3E}">
+        <p14:creationId xmlns:p14="http://schemas.microsoft.com/office/powerpoint/2010/main" val="1024086991"/>
+      </p:ext>
+    </p:extLst>
+  </p:cSld>
+  <p:clrMapOvr>
+    <a:masterClrMapping/>
+  </p:clrMapOvr>
+</p:notes>
+</file>
+
+<file path=ppt/notesSlides/notesSlide9.xml><?xml version="1.0" encoding="utf-8"?>
+<p:notes xmlns:a="http://schemas.openxmlformats.org/drawingml/2006/main" xmlns:r="http://schemas.openxmlformats.org/officeDocument/2006/relationships" xmlns:p="http://schemas.openxmlformats.org/presentationml/2006/main">
+  <p:cSld>
+    <p:spTree>
+      <p:nvGrpSpPr>
+        <p:cNvPr id="1" name=""/>
+        <p:cNvGrpSpPr/>
+        <p:nvPr/>
+      </p:nvGrpSpPr>
+      <p:grpSpPr>
+        <a:xfrm>
+          <a:off x="0" y="0"/>
+          <a:ext cx="0" cy="0"/>
+          <a:chOff x="0" y="0"/>
+          <a:chExt cx="0" cy="0"/>
+        </a:xfrm>
+      </p:grpSpPr>
+      <p:sp>
+        <p:nvSpPr>
+          <p:cNvPr id="2" name="Slide Image Placeholder 1"/>
+          <p:cNvSpPr>
+            <a:spLocks noGrp="1" noRot="1" noChangeAspect="1"/>
+          </p:cNvSpPr>
+          <p:nvPr>
+            <p:ph type="sldImg"/>
+          </p:nvPr>
+        </p:nvSpPr>
+        <p:spPr/>
+      </p:sp>
+      <p:sp>
+        <p:nvSpPr>
+          <p:cNvPr id="3" name="Notes Placeholder 2"/>
+          <p:cNvSpPr>
+            <a:spLocks noGrp="1"/>
+          </p:cNvSpPr>
+          <p:nvPr>
+            <p:ph type="body" idx="1"/>
+          </p:nvPr>
+        </p:nvSpPr>
+        <p:spPr/>
+        <p:txBody>
+          <a:bodyPr/>
+          <a:lstStyle/>
+          <a:p>
+            <a:r>
+              <a:rPr lang="en-US" dirty="0"/>
+              <a:t>Chốt: pipeline ổn, stopwords có ích nhưng chưa đủ; nút thắt thực sự là negation + concessive. Bộ câu khó dùng để đo tiến bộ sau khi sửa.</a:t>
+            </a:r>
+            <a:endParaRPr lang="en-US" dirty="0"/>
+          </a:p>
+        </p:txBody>
+      </p:sp>
+      <p:sp>
+        <p:nvSpPr>
+          <p:cNvPr id="4" name="Slide Number Placeholder 3"/>
+          <p:cNvSpPr>
+            <a:spLocks noGrp="1"/>
+          </p:cNvSpPr>
+          <p:nvPr>
+            <p:ph type="sldNum" sz="quarter" idx="10"/>
+          </p:nvPr>
+        </p:nvSpPr>
+        <p:spPr/>
+        <p:txBody>
+          <a:bodyPr/>
+          <a:lstStyle/>
+          <a:p>
+            <a:fld id="{F7021451-1387-4CA6-816F-3879F97B5CBC}" type="slidenum">
+              <a:rPr lang="en-US"/>
+              <a:t>9</a:t>
             </a:fld>
             <a:endParaRPr lang="en-US"/>
           </a:p>
@@ -5880,8 +5969,8 @@
         </p:nvSpPr>
         <p:spPr>
           <a:xfrm>
-            <a:off x="548640" y="365760"/>
-            <a:ext cx="11064240" cy="594360"/>
+            <a:off x="548640" y="320040"/>
+            <a:ext cx="11247120" cy="548640"/>
           </a:xfrm>
           <a:prstGeom prst="rect">
             <a:avLst/>
@@ -5897,7 +5986,7 @@
               <a:buNone/>
             </a:pPr>
             <a:r>
-              <a:rPr lang="en-US" sz="3000" b="1" dirty="0">
+              <a:rPr lang="en-US" sz="2600" b="1" dirty="0">
                 <a:solidFill>
                   <a:srgbClr val="21295C"/>
                 </a:solidFill>
@@ -5905,30 +5994,69 @@
                 <a:ea typeface="Cambria" pitchFamily="34" charset="-122"/>
                 <a:cs typeface="Cambria" pitchFamily="34" charset="-120"/>
               </a:rPr>
-              <a:t>Vì sao model sai? 3 nguyên nhân gốc</a:t>
-            </a:r>
-            <a:endParaRPr lang="en-US" sz="3000" dirty="0"/>
-          </a:p>
-        </p:txBody>
-      </p:sp>
-      <p:sp>
-        <p:nvSpPr>
-          <p:cNvPr id="3" name="Shape 1"/>
-          <p:cNvSpPr/>
-          <p:nvPr/>
-        </p:nvSpPr>
-        <p:spPr>
-          <a:xfrm>
-            <a:off x="548640" y="1143000"/>
-            <a:ext cx="11091672" cy="1463040"/>
+              <a:t>Mổ xẻ 3 câu model đoán sai (Exp A · ngưỡng 2.0)</a:t>
+            </a:r>
+            <a:endParaRPr lang="en-US" sz="2600" dirty="0"/>
+          </a:p>
+        </p:txBody>
+      </p:sp>
+      <p:sp>
+        <p:nvSpPr>
+          <p:cNvPr id="3" name="Text 1"/>
+          <p:cNvSpPr/>
+          <p:nvPr/>
+        </p:nvSpPr>
+        <p:spPr>
+          <a:xfrm>
+            <a:off x="548640" y="868680"/>
+            <a:ext cx="11247120" cy="320040"/>
+          </a:xfrm>
+          <a:prstGeom prst="rect">
+            <a:avLst/>
+          </a:prstGeom>
+          <a:noFill/>
+          <a:ln/>
+        </p:spPr>
+        <p:txBody>
+          <a:bodyPr wrap="square" lIns="0" tIns="0" rIns="0" bIns="0" rtlCol="0" anchor="ctr"/>
+          <a:lstStyle/>
+          <a:p>
+            <a:pPr indent="0" marL="0">
+              <a:buNone/>
+            </a:pPr>
+            <a:r>
+              <a:rPr lang="en-US" sz="1250" dirty="0">
+                <a:solidFill>
+                  <a:srgbClr val="5B6B79"/>
+                </a:solidFill>
+                <a:latin typeface="Calibri" pitchFamily="34" charset="0"/>
+                <a:ea typeface="Calibri" pitchFamily="34" charset="-122"/>
+                <a:cs typeface="Calibri" pitchFamily="34" charset="-120"/>
+              </a:rPr>
+              <a:t>Điểm cộng dồn từng token → thấy rõ chỗ sai. Xanh = +, Đỏ = −, Xám = phủ định/nhấn mạnh</a:t>
+            </a:r>
+            <a:endParaRPr lang="en-US" sz="1250" dirty="0"/>
+          </a:p>
+        </p:txBody>
+      </p:sp>
+      <p:sp>
+        <p:nvSpPr>
+          <p:cNvPr id="4" name="Shape 2"/>
+          <p:cNvSpPr/>
+          <p:nvPr/>
+        </p:nvSpPr>
+        <p:spPr>
+          <a:xfrm>
+            <a:off x="548640" y="1325880"/>
+            <a:ext cx="11091672" cy="1572768"/>
           </a:xfrm>
           <a:prstGeom prst="roundRect">
             <a:avLst>
-              <a:gd name="adj" fmla="val 6250"/>
+              <a:gd name="adj" fmla="val 5814"/>
             </a:avLst>
           </a:prstGeom>
           <a:solidFill>
-            <a:srgbClr val="EAF4F7"/>
+            <a:srgbClr val="F6F9FB"/>
           </a:solidFill>
           <a:ln/>
           <a:effectLst>
@@ -5942,17 +6070,58 @@
       </p:sp>
       <p:sp>
         <p:nvSpPr>
-          <p:cNvPr id="4" name="Shape 2"/>
-          <p:cNvSpPr/>
-          <p:nvPr/>
-        </p:nvSpPr>
-        <p:spPr>
-          <a:xfrm>
-            <a:off x="548640" y="1143000"/>
-            <a:ext cx="1965960" cy="1463040"/>
-          </a:xfrm>
-          <a:prstGeom prst="rect">
-            <a:avLst/>
+          <p:cNvPr id="5" name="Text 3"/>
+          <p:cNvSpPr/>
+          <p:nvPr/>
+        </p:nvSpPr>
+        <p:spPr>
+          <a:xfrm>
+            <a:off x="777240" y="1435608"/>
+            <a:ext cx="7772400" cy="365760"/>
+          </a:xfrm>
+          <a:prstGeom prst="rect">
+            <a:avLst/>
+          </a:prstGeom>
+          <a:noFill/>
+          <a:ln/>
+        </p:spPr>
+        <p:txBody>
+          <a:bodyPr wrap="square" lIns="0" tIns="0" rIns="0" bIns="0" rtlCol="0" anchor="ctr"/>
+          <a:lstStyle/>
+          <a:p>
+            <a:pPr indent="0" marL="0">
+              <a:buNone/>
+            </a:pPr>
+            <a:r>
+              <a:rPr lang="en-US" sz="1450" b="1" dirty="0">
+                <a:solidFill>
+                  <a:srgbClr val="21295C"/>
+                </a:solidFill>
+                <a:latin typeface="Calibri" pitchFamily="34" charset="0"/>
+                <a:ea typeface="Calibri" pitchFamily="34" charset="-122"/>
+                <a:cs typeface="Calibri" pitchFamily="34" charset="-120"/>
+              </a:rPr>
+              <a:t>“Tuy tận tâm nhưng dạy cực kỳ mơ hồ.”</a:t>
+            </a:r>
+            <a:endParaRPr lang="en-US" sz="1450" dirty="0"/>
+          </a:p>
+        </p:txBody>
+      </p:sp>
+      <p:sp>
+        <p:nvSpPr>
+          <p:cNvPr id="6" name="Shape 4"/>
+          <p:cNvSpPr/>
+          <p:nvPr/>
+        </p:nvSpPr>
+        <p:spPr>
+          <a:xfrm>
+            <a:off x="8686800" y="1453896"/>
+            <a:ext cx="2834640" cy="384048"/>
+          </a:xfrm>
+          <a:prstGeom prst="roundRect">
+            <a:avLst>
+              <a:gd name="adj" fmla="val 23810"/>
+            </a:avLst>
           </a:prstGeom>
           <a:solidFill>
             <a:srgbClr val="E4572E"/>
@@ -5962,14 +6131,14 @@
       </p:sp>
       <p:sp>
         <p:nvSpPr>
-          <p:cNvPr id="5" name="Text 3"/>
-          <p:cNvSpPr/>
-          <p:nvPr/>
-        </p:nvSpPr>
-        <p:spPr>
-          <a:xfrm>
-            <a:off x="640080" y="1143000"/>
-            <a:ext cx="1783080" cy="1463040"/>
+          <p:cNvPr id="7" name="Text 5"/>
+          <p:cNvSpPr/>
+          <p:nvPr/>
+        </p:nvSpPr>
+        <p:spPr>
+          <a:xfrm>
+            <a:off x="8686800" y="1453896"/>
+            <a:ext cx="2834640" cy="384048"/>
           </a:xfrm>
           <a:prstGeom prst="rect">
             <a:avLst/>
@@ -5985,7 +6154,7 @@
               <a:buNone/>
             </a:pPr>
             <a:r>
-              <a:rPr lang="en-US" sz="1500" b="1" dirty="0">
+              <a:rPr lang="en-US" sz="1100" b="1" dirty="0">
                 <a:solidFill>
                   <a:srgbClr val="FFFFFF"/>
                 </a:solidFill>
@@ -5993,90 +6162,9 @@
                 <a:ea typeface="Calibri" pitchFamily="34" charset="-122"/>
                 <a:cs typeface="Calibri" pitchFamily="34" charset="-120"/>
               </a:rPr>
-              <a:t>Negation</a:t>
-            </a:r>
-            <a:endParaRPr lang="en-US" sz="1500" dirty="0"/>
-          </a:p>
-        </p:txBody>
-      </p:sp>
-      <p:sp>
-        <p:nvSpPr>
-          <p:cNvPr id="6" name="Text 4"/>
-          <p:cNvSpPr/>
-          <p:nvPr/>
-        </p:nvSpPr>
-        <p:spPr>
-          <a:xfrm>
-            <a:off x="2697480" y="1344168"/>
-            <a:ext cx="8686800" cy="457200"/>
-          </a:xfrm>
-          <a:prstGeom prst="rect">
-            <a:avLst/>
-          </a:prstGeom>
-          <a:noFill/>
-          <a:ln/>
-        </p:spPr>
-        <p:txBody>
-          <a:bodyPr wrap="square" lIns="0" tIns="0" rIns="0" bIns="0" rtlCol="0" anchor="ctr"/>
-          <a:lstStyle/>
-          <a:p>
-            <a:pPr indent="0" marL="0">
-              <a:buNone/>
-            </a:pPr>
-            <a:r>
-              <a:rPr lang="en-US" sz="1600" b="1" dirty="0">
-                <a:solidFill>
-                  <a:srgbClr val="21295C"/>
-                </a:solidFill>
-                <a:latin typeface="Calibri" pitchFamily="34" charset="0"/>
-                <a:ea typeface="Calibri" pitchFamily="34" charset="-122"/>
-                <a:cs typeface="Calibri" pitchFamily="34" charset="-120"/>
-              </a:rPr>
-              <a:t>Phủ định chỉ tác dụng trong cửa sổ hẹp</a:t>
-            </a:r>
-            <a:endParaRPr lang="en-US" sz="1600" dirty="0"/>
-          </a:p>
-        </p:txBody>
-      </p:sp>
-      <p:sp>
-        <p:nvSpPr>
-          <p:cNvPr id="7" name="Text 5"/>
-          <p:cNvSpPr/>
-          <p:nvPr/>
-        </p:nvSpPr>
-        <p:spPr>
-          <a:xfrm>
-            <a:off x="2697480" y="1801368"/>
-            <a:ext cx="8732520" cy="685800"/>
-          </a:xfrm>
-          <a:prstGeom prst="rect">
-            <a:avLst/>
-          </a:prstGeom>
-          <a:noFill/>
-          <a:ln/>
-        </p:spPr>
-        <p:txBody>
-          <a:bodyPr wrap="square" lIns="0" tIns="0" rIns="0" bIns="0" rtlCol="0" anchor="ctr"/>
-          <a:lstStyle/>
-          <a:p>
-            <a:pPr indent="0" marL="0">
-              <a:lnSpc>
-                <a:spcPct val="110000"/>
-              </a:lnSpc>
-              <a:buNone/>
-            </a:pPr>
-            <a:r>
-              <a:rPr lang="en-US" sz="1250" dirty="0">
-                <a:solidFill>
-                  <a:srgbClr val="5B6B79"/>
-                </a:solidFill>
-                <a:latin typeface="Calibri" pitchFamily="34" charset="0"/>
-                <a:ea typeface="Calibri" pitchFamily="34" charset="-122"/>
-                <a:cs typeface="Calibri" pitchFamily="34" charset="-120"/>
-              </a:rPr>
-              <a:t>“chưa”, “không” chỉ đảo dấu vài token kế; từ cảm xúc nằm ngoài cửa sổ không bị đảo → câu tiêu cực vẫn dương.</a:t>
-            </a:r>
-            <a:endParaRPr lang="en-US" sz="1250" dirty="0"/>
+              <a:t>Nhượng bộ · Neg → Pos ✗</a:t>
+            </a:r>
+            <a:endParaRPr lang="en-US" sz="1100" dirty="0"/>
           </a:p>
         </p:txBody>
       </p:sp>
@@ -6088,16 +6176,738 @@
         </p:nvSpPr>
         <p:spPr>
           <a:xfrm>
-            <a:off x="548640" y="2770632"/>
-            <a:ext cx="11091672" cy="1463040"/>
+            <a:off x="777240" y="1947672"/>
+            <a:ext cx="1042416" cy="658368"/>
           </a:xfrm>
           <a:prstGeom prst="roundRect">
             <a:avLst>
-              <a:gd name="adj" fmla="val 6250"/>
+              <a:gd name="adj" fmla="val 9722"/>
             </a:avLst>
           </a:prstGeom>
           <a:solidFill>
-            <a:srgbClr val="EAF4F7"/>
+            <a:srgbClr val="E4F3EE"/>
+          </a:solidFill>
+          <a:ln/>
+        </p:spPr>
+      </p:sp>
+      <p:sp>
+        <p:nvSpPr>
+          <p:cNvPr id="9" name="Text 7"/>
+          <p:cNvSpPr/>
+          <p:nvPr/>
+        </p:nvSpPr>
+        <p:spPr>
+          <a:xfrm>
+            <a:off x="777240" y="1993392"/>
+            <a:ext cx="1042416" cy="310896"/>
+          </a:xfrm>
+          <a:prstGeom prst="rect">
+            <a:avLst/>
+          </a:prstGeom>
+          <a:noFill/>
+          <a:ln/>
+        </p:spPr>
+        <p:txBody>
+          <a:bodyPr wrap="square" lIns="0" tIns="0" rIns="0" bIns="0" rtlCol="0" anchor="ctr"/>
+          <a:lstStyle/>
+          <a:p>
+            <a:pPr algn="ctr" indent="0" marL="0">
+              <a:buNone/>
+            </a:pPr>
+            <a:r>
+              <a:rPr lang="en-US" sz="1050" b="1" dirty="0">
+                <a:solidFill>
+                  <a:srgbClr val="21295C"/>
+                </a:solidFill>
+                <a:latin typeface="Calibri" pitchFamily="34" charset="0"/>
+                <a:ea typeface="Calibri" pitchFamily="34" charset="-122"/>
+                <a:cs typeface="Calibri" pitchFamily="34" charset="-120"/>
+              </a:rPr>
+              <a:t>tuy</a:t>
+            </a:r>
+            <a:endParaRPr lang="en-US" sz="1050" dirty="0"/>
+          </a:p>
+        </p:txBody>
+      </p:sp>
+      <p:sp>
+        <p:nvSpPr>
+          <p:cNvPr id="10" name="Text 8"/>
+          <p:cNvSpPr/>
+          <p:nvPr/>
+        </p:nvSpPr>
+        <p:spPr>
+          <a:xfrm>
+            <a:off x="777240" y="2286000"/>
+            <a:ext cx="1042416" cy="274320"/>
+          </a:xfrm>
+          <a:prstGeom prst="rect">
+            <a:avLst/>
+          </a:prstGeom>
+          <a:noFill/>
+          <a:ln/>
+        </p:spPr>
+        <p:txBody>
+          <a:bodyPr wrap="square" lIns="0" tIns="0" rIns="0" bIns="0" rtlCol="0" anchor="ctr"/>
+          <a:lstStyle/>
+          <a:p>
+            <a:pPr algn="ctr" indent="0" marL="0">
+              <a:buNone/>
+            </a:pPr>
+            <a:r>
+              <a:rPr lang="en-US" sz="1100" b="1" dirty="0">
+                <a:solidFill>
+                  <a:srgbClr val="3FA796"/>
+                </a:solidFill>
+                <a:latin typeface="Calibri" pitchFamily="34" charset="0"/>
+                <a:ea typeface="Calibri" pitchFamily="34" charset="-122"/>
+                <a:cs typeface="Calibri" pitchFamily="34" charset="-120"/>
+              </a:rPr>
+              <a:t>+1</a:t>
+            </a:r>
+            <a:endParaRPr lang="en-US" sz="1100" dirty="0"/>
+          </a:p>
+        </p:txBody>
+      </p:sp>
+      <p:sp>
+        <p:nvSpPr>
+          <p:cNvPr id="11" name="Shape 9"/>
+          <p:cNvSpPr/>
+          <p:nvPr/>
+        </p:nvSpPr>
+        <p:spPr>
+          <a:xfrm>
+            <a:off x="1911096" y="1947672"/>
+            <a:ext cx="1042416" cy="658368"/>
+          </a:xfrm>
+          <a:prstGeom prst="roundRect">
+            <a:avLst>
+              <a:gd name="adj" fmla="val 9722"/>
+            </a:avLst>
+          </a:prstGeom>
+          <a:solidFill>
+            <a:srgbClr val="E4F3EE"/>
+          </a:solidFill>
+          <a:ln/>
+        </p:spPr>
+      </p:sp>
+      <p:sp>
+        <p:nvSpPr>
+          <p:cNvPr id="12" name="Text 10"/>
+          <p:cNvSpPr/>
+          <p:nvPr/>
+        </p:nvSpPr>
+        <p:spPr>
+          <a:xfrm>
+            <a:off x="1911096" y="1993392"/>
+            <a:ext cx="1042416" cy="310896"/>
+          </a:xfrm>
+          <a:prstGeom prst="rect">
+            <a:avLst/>
+          </a:prstGeom>
+          <a:noFill/>
+          <a:ln/>
+        </p:spPr>
+        <p:txBody>
+          <a:bodyPr wrap="square" lIns="0" tIns="0" rIns="0" bIns="0" rtlCol="0" anchor="ctr"/>
+          <a:lstStyle/>
+          <a:p>
+            <a:pPr algn="ctr" indent="0" marL="0">
+              <a:buNone/>
+            </a:pPr>
+            <a:r>
+              <a:rPr lang="en-US" sz="1050" b="1" dirty="0">
+                <a:solidFill>
+                  <a:srgbClr val="21295C"/>
+                </a:solidFill>
+                <a:latin typeface="Calibri" pitchFamily="34" charset="0"/>
+                <a:ea typeface="Calibri" pitchFamily="34" charset="-122"/>
+                <a:cs typeface="Calibri" pitchFamily="34" charset="-120"/>
+              </a:rPr>
+              <a:t>tận tâm</a:t>
+            </a:r>
+            <a:endParaRPr lang="en-US" sz="1050" dirty="0"/>
+          </a:p>
+        </p:txBody>
+      </p:sp>
+      <p:sp>
+        <p:nvSpPr>
+          <p:cNvPr id="13" name="Text 11"/>
+          <p:cNvSpPr/>
+          <p:nvPr/>
+        </p:nvSpPr>
+        <p:spPr>
+          <a:xfrm>
+            <a:off x="1911096" y="2286000"/>
+            <a:ext cx="1042416" cy="274320"/>
+          </a:xfrm>
+          <a:prstGeom prst="rect">
+            <a:avLst/>
+          </a:prstGeom>
+          <a:noFill/>
+          <a:ln/>
+        </p:spPr>
+        <p:txBody>
+          <a:bodyPr wrap="square" lIns="0" tIns="0" rIns="0" bIns="0" rtlCol="0" anchor="ctr"/>
+          <a:lstStyle/>
+          <a:p>
+            <a:pPr algn="ctr" indent="0" marL="0">
+              <a:buNone/>
+            </a:pPr>
+            <a:r>
+              <a:rPr lang="en-US" sz="1100" b="1" dirty="0">
+                <a:solidFill>
+                  <a:srgbClr val="3FA796"/>
+                </a:solidFill>
+                <a:latin typeface="Calibri" pitchFamily="34" charset="0"/>
+                <a:ea typeface="Calibri" pitchFamily="34" charset="-122"/>
+                <a:cs typeface="Calibri" pitchFamily="34" charset="-120"/>
+              </a:rPr>
+              <a:t>+1</a:t>
+            </a:r>
+            <a:endParaRPr lang="en-US" sz="1100" dirty="0"/>
+          </a:p>
+        </p:txBody>
+      </p:sp>
+      <p:sp>
+        <p:nvSpPr>
+          <p:cNvPr id="14" name="Shape 12"/>
+          <p:cNvSpPr/>
+          <p:nvPr/>
+        </p:nvSpPr>
+        <p:spPr>
+          <a:xfrm>
+            <a:off x="3044952" y="1947672"/>
+            <a:ext cx="1042416" cy="658368"/>
+          </a:xfrm>
+          <a:prstGeom prst="roundRect">
+            <a:avLst>
+              <a:gd name="adj" fmla="val 9722"/>
+            </a:avLst>
+          </a:prstGeom>
+          <a:solidFill>
+            <a:srgbClr val="E4F3EE"/>
+          </a:solidFill>
+          <a:ln/>
+        </p:spPr>
+      </p:sp>
+      <p:sp>
+        <p:nvSpPr>
+          <p:cNvPr id="15" name="Text 13"/>
+          <p:cNvSpPr/>
+          <p:nvPr/>
+        </p:nvSpPr>
+        <p:spPr>
+          <a:xfrm>
+            <a:off x="3044952" y="1993392"/>
+            <a:ext cx="1042416" cy="310896"/>
+          </a:xfrm>
+          <a:prstGeom prst="rect">
+            <a:avLst/>
+          </a:prstGeom>
+          <a:noFill/>
+          <a:ln/>
+        </p:spPr>
+        <p:txBody>
+          <a:bodyPr wrap="square" lIns="0" tIns="0" rIns="0" bIns="0" rtlCol="0" anchor="ctr"/>
+          <a:lstStyle/>
+          <a:p>
+            <a:pPr algn="ctr" indent="0" marL="0">
+              <a:buNone/>
+            </a:pPr>
+            <a:r>
+              <a:rPr lang="en-US" sz="1050" b="1" dirty="0">
+                <a:solidFill>
+                  <a:srgbClr val="21295C"/>
+                </a:solidFill>
+                <a:latin typeface="Calibri" pitchFamily="34" charset="0"/>
+                <a:ea typeface="Calibri" pitchFamily="34" charset="-122"/>
+                <a:cs typeface="Calibri" pitchFamily="34" charset="-120"/>
+              </a:rPr>
+              <a:t>nhưng</a:t>
+            </a:r>
+            <a:endParaRPr lang="en-US" sz="1050" dirty="0"/>
+          </a:p>
+        </p:txBody>
+      </p:sp>
+      <p:sp>
+        <p:nvSpPr>
+          <p:cNvPr id="16" name="Text 14"/>
+          <p:cNvSpPr/>
+          <p:nvPr/>
+        </p:nvSpPr>
+        <p:spPr>
+          <a:xfrm>
+            <a:off x="3044952" y="2286000"/>
+            <a:ext cx="1042416" cy="274320"/>
+          </a:xfrm>
+          <a:prstGeom prst="rect">
+            <a:avLst/>
+          </a:prstGeom>
+          <a:noFill/>
+          <a:ln/>
+        </p:spPr>
+        <p:txBody>
+          <a:bodyPr wrap="square" lIns="0" tIns="0" rIns="0" bIns="0" rtlCol="0" anchor="ctr"/>
+          <a:lstStyle/>
+          <a:p>
+            <a:pPr algn="ctr" indent="0" marL="0">
+              <a:buNone/>
+            </a:pPr>
+            <a:r>
+              <a:rPr lang="en-US" sz="1100" b="1" dirty="0">
+                <a:solidFill>
+                  <a:srgbClr val="3FA796"/>
+                </a:solidFill>
+                <a:latin typeface="Calibri" pitchFamily="34" charset="0"/>
+                <a:ea typeface="Calibri" pitchFamily="34" charset="-122"/>
+                <a:cs typeface="Calibri" pitchFamily="34" charset="-120"/>
+              </a:rPr>
+              <a:t>+1</a:t>
+            </a:r>
+            <a:endParaRPr lang="en-US" sz="1100" dirty="0"/>
+          </a:p>
+        </p:txBody>
+      </p:sp>
+      <p:sp>
+        <p:nvSpPr>
+          <p:cNvPr id="17" name="Shape 15"/>
+          <p:cNvSpPr/>
+          <p:nvPr/>
+        </p:nvSpPr>
+        <p:spPr>
+          <a:xfrm>
+            <a:off x="4178808" y="1947672"/>
+            <a:ext cx="1042416" cy="658368"/>
+          </a:xfrm>
+          <a:prstGeom prst="roundRect">
+            <a:avLst>
+              <a:gd name="adj" fmla="val 9722"/>
+            </a:avLst>
+          </a:prstGeom>
+          <a:solidFill>
+            <a:srgbClr val="E4F3EE"/>
+          </a:solidFill>
+          <a:ln/>
+        </p:spPr>
+      </p:sp>
+      <p:sp>
+        <p:nvSpPr>
+          <p:cNvPr id="18" name="Text 16"/>
+          <p:cNvSpPr/>
+          <p:nvPr/>
+        </p:nvSpPr>
+        <p:spPr>
+          <a:xfrm>
+            <a:off x="4178808" y="1993392"/>
+            <a:ext cx="1042416" cy="310896"/>
+          </a:xfrm>
+          <a:prstGeom prst="rect">
+            <a:avLst/>
+          </a:prstGeom>
+          <a:noFill/>
+          <a:ln/>
+        </p:spPr>
+        <p:txBody>
+          <a:bodyPr wrap="square" lIns="0" tIns="0" rIns="0" bIns="0" rtlCol="0" anchor="ctr"/>
+          <a:lstStyle/>
+          <a:p>
+            <a:pPr algn="ctr" indent="0" marL="0">
+              <a:buNone/>
+            </a:pPr>
+            <a:r>
+              <a:rPr lang="en-US" sz="1050" b="1" dirty="0">
+                <a:solidFill>
+                  <a:srgbClr val="21295C"/>
+                </a:solidFill>
+                <a:latin typeface="Calibri" pitchFamily="34" charset="0"/>
+                <a:ea typeface="Calibri" pitchFamily="34" charset="-122"/>
+                <a:cs typeface="Calibri" pitchFamily="34" charset="-120"/>
+              </a:rPr>
+              <a:t>dạy</a:t>
+            </a:r>
+            <a:endParaRPr lang="en-US" sz="1050" dirty="0"/>
+          </a:p>
+        </p:txBody>
+      </p:sp>
+      <p:sp>
+        <p:nvSpPr>
+          <p:cNvPr id="19" name="Text 17"/>
+          <p:cNvSpPr/>
+          <p:nvPr/>
+        </p:nvSpPr>
+        <p:spPr>
+          <a:xfrm>
+            <a:off x="4178808" y="2286000"/>
+            <a:ext cx="1042416" cy="274320"/>
+          </a:xfrm>
+          <a:prstGeom prst="rect">
+            <a:avLst/>
+          </a:prstGeom>
+          <a:noFill/>
+          <a:ln/>
+        </p:spPr>
+        <p:txBody>
+          <a:bodyPr wrap="square" lIns="0" tIns="0" rIns="0" bIns="0" rtlCol="0" anchor="ctr"/>
+          <a:lstStyle/>
+          <a:p>
+            <a:pPr algn="ctr" indent="0" marL="0">
+              <a:buNone/>
+            </a:pPr>
+            <a:r>
+              <a:rPr lang="en-US" sz="1100" b="1" dirty="0">
+                <a:solidFill>
+                  <a:srgbClr val="3FA796"/>
+                </a:solidFill>
+                <a:latin typeface="Calibri" pitchFamily="34" charset="0"/>
+                <a:ea typeface="Calibri" pitchFamily="34" charset="-122"/>
+                <a:cs typeface="Calibri" pitchFamily="34" charset="-120"/>
+              </a:rPr>
+              <a:t>+1</a:t>
+            </a:r>
+            <a:endParaRPr lang="en-US" sz="1100" dirty="0"/>
+          </a:p>
+        </p:txBody>
+      </p:sp>
+      <p:sp>
+        <p:nvSpPr>
+          <p:cNvPr id="20" name="Shape 18"/>
+          <p:cNvSpPr/>
+          <p:nvPr/>
+        </p:nvSpPr>
+        <p:spPr>
+          <a:xfrm>
+            <a:off x="5312664" y="1947672"/>
+            <a:ext cx="1042416" cy="658368"/>
+          </a:xfrm>
+          <a:prstGeom prst="roundRect">
+            <a:avLst>
+              <a:gd name="adj" fmla="val 9722"/>
+            </a:avLst>
+          </a:prstGeom>
+          <a:solidFill>
+            <a:srgbClr val="E5ECF3"/>
+          </a:solidFill>
+          <a:ln/>
+        </p:spPr>
+      </p:sp>
+      <p:sp>
+        <p:nvSpPr>
+          <p:cNvPr id="21" name="Text 19"/>
+          <p:cNvSpPr/>
+          <p:nvPr/>
+        </p:nvSpPr>
+        <p:spPr>
+          <a:xfrm>
+            <a:off x="5312664" y="1993392"/>
+            <a:ext cx="1042416" cy="310896"/>
+          </a:xfrm>
+          <a:prstGeom prst="rect">
+            <a:avLst/>
+          </a:prstGeom>
+          <a:noFill/>
+          <a:ln/>
+        </p:spPr>
+        <p:txBody>
+          <a:bodyPr wrap="square" lIns="0" tIns="0" rIns="0" bIns="0" rtlCol="0" anchor="ctr"/>
+          <a:lstStyle/>
+          <a:p>
+            <a:pPr algn="ctr" indent="0" marL="0">
+              <a:buNone/>
+            </a:pPr>
+            <a:r>
+              <a:rPr lang="en-US" sz="1050" b="1" dirty="0">
+                <a:solidFill>
+                  <a:srgbClr val="21295C"/>
+                </a:solidFill>
+                <a:latin typeface="Calibri" pitchFamily="34" charset="0"/>
+                <a:ea typeface="Calibri" pitchFamily="34" charset="-122"/>
+                <a:cs typeface="Calibri" pitchFamily="34" charset="-120"/>
+              </a:rPr>
+              <a:t>cực kỳ</a:t>
+            </a:r>
+            <a:endParaRPr lang="en-US" sz="1050" dirty="0"/>
+          </a:p>
+        </p:txBody>
+      </p:sp>
+      <p:sp>
+        <p:nvSpPr>
+          <p:cNvPr id="22" name="Text 20"/>
+          <p:cNvSpPr/>
+          <p:nvPr/>
+        </p:nvSpPr>
+        <p:spPr>
+          <a:xfrm>
+            <a:off x="5312664" y="2286000"/>
+            <a:ext cx="1042416" cy="274320"/>
+          </a:xfrm>
+          <a:prstGeom prst="rect">
+            <a:avLst/>
+          </a:prstGeom>
+          <a:noFill/>
+          <a:ln/>
+        </p:spPr>
+        <p:txBody>
+          <a:bodyPr wrap="square" lIns="0" tIns="0" rIns="0" bIns="0" rtlCol="0" anchor="ctr"/>
+          <a:lstStyle/>
+          <a:p>
+            <a:pPr algn="ctr" indent="0" marL="0">
+              <a:buNone/>
+            </a:pPr>
+            <a:r>
+              <a:rPr lang="en-US" sz="1100" b="1" dirty="0">
+                <a:solidFill>
+                  <a:srgbClr val="065A82"/>
+                </a:solidFill>
+                <a:latin typeface="Calibri" pitchFamily="34" charset="0"/>
+                <a:ea typeface="Calibri" pitchFamily="34" charset="-122"/>
+                <a:cs typeface="Calibri" pitchFamily="34" charset="-120"/>
+              </a:rPr>
+              <a:t>×2</a:t>
+            </a:r>
+            <a:endParaRPr lang="en-US" sz="1100" dirty="0"/>
+          </a:p>
+        </p:txBody>
+      </p:sp>
+      <p:sp>
+        <p:nvSpPr>
+          <p:cNvPr id="23" name="Shape 21"/>
+          <p:cNvSpPr/>
+          <p:nvPr/>
+        </p:nvSpPr>
+        <p:spPr>
+          <a:xfrm>
+            <a:off x="6446520" y="1947672"/>
+            <a:ext cx="1042416" cy="658368"/>
+          </a:xfrm>
+          <a:prstGeom prst="roundRect">
+            <a:avLst>
+              <a:gd name="adj" fmla="val 9722"/>
+            </a:avLst>
+          </a:prstGeom>
+          <a:solidFill>
+            <a:srgbClr val="FBE9E4"/>
+          </a:solidFill>
+          <a:ln/>
+        </p:spPr>
+      </p:sp>
+      <p:sp>
+        <p:nvSpPr>
+          <p:cNvPr id="24" name="Text 22"/>
+          <p:cNvSpPr/>
+          <p:nvPr/>
+        </p:nvSpPr>
+        <p:spPr>
+          <a:xfrm>
+            <a:off x="6446520" y="1993392"/>
+            <a:ext cx="1042416" cy="310896"/>
+          </a:xfrm>
+          <a:prstGeom prst="rect">
+            <a:avLst/>
+          </a:prstGeom>
+          <a:noFill/>
+          <a:ln/>
+        </p:spPr>
+        <p:txBody>
+          <a:bodyPr wrap="square" lIns="0" tIns="0" rIns="0" bIns="0" rtlCol="0" anchor="ctr"/>
+          <a:lstStyle/>
+          <a:p>
+            <a:pPr algn="ctr" indent="0" marL="0">
+              <a:buNone/>
+            </a:pPr>
+            <a:r>
+              <a:rPr lang="en-US" sz="1050" b="1" dirty="0">
+                <a:solidFill>
+                  <a:srgbClr val="21295C"/>
+                </a:solidFill>
+                <a:latin typeface="Calibri" pitchFamily="34" charset="0"/>
+                <a:ea typeface="Calibri" pitchFamily="34" charset="-122"/>
+                <a:cs typeface="Calibri" pitchFamily="34" charset="-120"/>
+              </a:rPr>
+              <a:t>mơ hồ</a:t>
+            </a:r>
+            <a:endParaRPr lang="en-US" sz="1050" dirty="0"/>
+          </a:p>
+        </p:txBody>
+      </p:sp>
+      <p:sp>
+        <p:nvSpPr>
+          <p:cNvPr id="25" name="Text 23"/>
+          <p:cNvSpPr/>
+          <p:nvPr/>
+        </p:nvSpPr>
+        <p:spPr>
+          <a:xfrm>
+            <a:off x="6446520" y="2286000"/>
+            <a:ext cx="1042416" cy="274320"/>
+          </a:xfrm>
+          <a:prstGeom prst="rect">
+            <a:avLst/>
+          </a:prstGeom>
+          <a:noFill/>
+          <a:ln/>
+        </p:spPr>
+        <p:txBody>
+          <a:bodyPr wrap="square" lIns="0" tIns="0" rIns="0" bIns="0" rtlCol="0" anchor="ctr"/>
+          <a:lstStyle/>
+          <a:p>
+            <a:pPr algn="ctr" indent="0" marL="0">
+              <a:buNone/>
+            </a:pPr>
+            <a:r>
+              <a:rPr lang="en-US" sz="1100" b="1" dirty="0">
+                <a:solidFill>
+                  <a:srgbClr val="E4572E"/>
+                </a:solidFill>
+                <a:latin typeface="Calibri" pitchFamily="34" charset="0"/>
+                <a:ea typeface="Calibri" pitchFamily="34" charset="-122"/>
+                <a:cs typeface="Calibri" pitchFamily="34" charset="-120"/>
+              </a:rPr>
+              <a:t>−2</a:t>
+            </a:r>
+            <a:endParaRPr lang="en-US" sz="1100" dirty="0"/>
+          </a:p>
+        </p:txBody>
+      </p:sp>
+      <p:sp>
+        <p:nvSpPr>
+          <p:cNvPr id="26" name="Shape 24"/>
+          <p:cNvSpPr/>
+          <p:nvPr/>
+        </p:nvSpPr>
+        <p:spPr>
+          <a:xfrm>
+            <a:off x="7717536" y="1947672"/>
+            <a:ext cx="2286000" cy="658368"/>
+          </a:xfrm>
+          <a:prstGeom prst="roundRect">
+            <a:avLst>
+              <a:gd name="adj" fmla="val 11111"/>
+            </a:avLst>
+          </a:prstGeom>
+          <a:solidFill>
+            <a:srgbClr val="21295C"/>
+          </a:solidFill>
+          <a:ln/>
+        </p:spPr>
+      </p:sp>
+      <p:sp>
+        <p:nvSpPr>
+          <p:cNvPr id="27" name="Text 25"/>
+          <p:cNvSpPr/>
+          <p:nvPr/>
+        </p:nvSpPr>
+        <p:spPr>
+          <a:xfrm>
+            <a:off x="7717536" y="1947672"/>
+            <a:ext cx="2286000" cy="658368"/>
+          </a:xfrm>
+          <a:prstGeom prst="rect">
+            <a:avLst/>
+          </a:prstGeom>
+          <a:noFill/>
+          <a:ln/>
+        </p:spPr>
+        <p:txBody>
+          <a:bodyPr wrap="square" lIns="0" tIns="0" rIns="0" bIns="0" rtlCol="0" anchor="ctr"/>
+          <a:lstStyle/>
+          <a:p>
+            <a:pPr algn="ctr" indent="0" marL="0">
+              <a:buNone/>
+            </a:pPr>
+            <a:r>
+              <a:rPr lang="en-US" sz="1300" b="1" dirty="0">
+                <a:solidFill>
+                  <a:srgbClr val="FFFFFF"/>
+                </a:solidFill>
+              </a:rPr>
+              <a:t>Σ = +2.0  </a:t>
+            </a:r>
+            <a:pPr algn="ctr" indent="0" marL="0">
+              <a:buNone/>
+            </a:pPr>
+            <a:r>
+              <a:rPr lang="en-US" sz="1200" b="1" dirty="0">
+                <a:solidFill>
+                  <a:srgbClr val="E4572E"/>
+                </a:solidFill>
+              </a:rPr>
+              <a:t>→ Positive</a:t>
+            </a:r>
+            <a:endParaRPr lang="en-US" sz="1300" dirty="0"/>
+          </a:p>
+        </p:txBody>
+      </p:sp>
+      <p:sp>
+        <p:nvSpPr>
+          <p:cNvPr id="28" name="Text 26"/>
+          <p:cNvSpPr/>
+          <p:nvPr/>
+        </p:nvSpPr>
+        <p:spPr>
+          <a:xfrm>
+            <a:off x="777240" y="2624328"/>
+            <a:ext cx="10607040" cy="256032"/>
+          </a:xfrm>
+          <a:prstGeom prst="rect">
+            <a:avLst/>
+          </a:prstGeom>
+          <a:noFill/>
+          <a:ln/>
+        </p:spPr>
+        <p:txBody>
+          <a:bodyPr wrap="square" lIns="0" tIns="0" rIns="0" bIns="0" rtlCol="0" anchor="ctr"/>
+          <a:lstStyle/>
+          <a:p>
+            <a:pPr indent="0" marL="0">
+              <a:buNone/>
+            </a:pPr>
+            <a:r>
+              <a:rPr lang="en-US" sz="1150" b="1" dirty="0">
+                <a:solidFill>
+                  <a:srgbClr val="1C7293"/>
+                </a:solidFill>
+                <a:latin typeface="Calibri" pitchFamily="34" charset="0"/>
+                <a:ea typeface="Calibri" pitchFamily="34" charset="-122"/>
+                <a:cs typeface="Calibri" pitchFamily="34" charset="-120"/>
+              </a:rPr>
+              <a:t>Vì sao:  </a:t>
+            </a:r>
+            <a:pPr indent="0" marL="0">
+              <a:buNone/>
+            </a:pPr>
+            <a:r>
+              <a:rPr lang="en-US" sz="1150" dirty="0">
+                <a:solidFill>
+                  <a:srgbClr val="5B6B79"/>
+                </a:solidFill>
+                <a:latin typeface="Calibri" pitchFamily="34" charset="0"/>
+                <a:ea typeface="Calibri" pitchFamily="34" charset="-122"/>
+                <a:cs typeface="Calibri" pitchFamily="34" charset="-120"/>
+              </a:rPr>
+              <a:t>Cộng điểm cả 2 vế; hư từ “tuy/nhưng/dạy” đều bị tính +1 → vế chê “mơ hồ” (−2) không kéo lại đủ.</a:t>
+            </a:r>
+            <a:endParaRPr lang="en-US" sz="1150" dirty="0"/>
+          </a:p>
+        </p:txBody>
+      </p:sp>
+      <p:sp>
+        <p:nvSpPr>
+          <p:cNvPr id="29" name="Shape 27"/>
+          <p:cNvSpPr/>
+          <p:nvPr/>
+        </p:nvSpPr>
+        <p:spPr>
+          <a:xfrm>
+            <a:off x="548640" y="3044952"/>
+            <a:ext cx="11091672" cy="1572768"/>
+          </a:xfrm>
+          <a:prstGeom prst="roundRect">
+            <a:avLst>
+              <a:gd name="adj" fmla="val 5814"/>
+            </a:avLst>
+          </a:prstGeom>
+          <a:solidFill>
+            <a:srgbClr val="F6F9FB"/>
           </a:solidFill>
           <a:ln/>
           <a:effectLst>
@@ -6111,17 +6921,58 @@
       </p:sp>
       <p:sp>
         <p:nvSpPr>
-          <p:cNvPr id="9" name="Shape 7"/>
-          <p:cNvSpPr/>
-          <p:nvPr/>
-        </p:nvSpPr>
-        <p:spPr>
-          <a:xfrm>
-            <a:off x="548640" y="2770632"/>
-            <a:ext cx="1965960" cy="1463040"/>
-          </a:xfrm>
-          <a:prstGeom prst="rect">
-            <a:avLst/>
+          <p:cNvPr id="30" name="Text 28"/>
+          <p:cNvSpPr/>
+          <p:nvPr/>
+        </p:nvSpPr>
+        <p:spPr>
+          <a:xfrm>
+            <a:off x="777240" y="3154680"/>
+            <a:ext cx="7772400" cy="365760"/>
+          </a:xfrm>
+          <a:prstGeom prst="rect">
+            <a:avLst/>
+          </a:prstGeom>
+          <a:noFill/>
+          <a:ln/>
+        </p:spPr>
+        <p:txBody>
+          <a:bodyPr wrap="square" lIns="0" tIns="0" rIns="0" bIns="0" rtlCol="0" anchor="ctr"/>
+          <a:lstStyle/>
+          <a:p>
+            <a:pPr indent="0" marL="0">
+              <a:buNone/>
+            </a:pPr>
+            <a:r>
+              <a:rPr lang="en-US" sz="1450" b="1" dirty="0">
+                <a:solidFill>
+                  <a:srgbClr val="21295C"/>
+                </a:solidFill>
+                <a:latin typeface="Calibri" pitchFamily="34" charset="0"/>
+                <a:ea typeface="Calibri" pitchFamily="34" charset="-122"/>
+                <a:cs typeface="Calibri" pitchFamily="34" charset="-120"/>
+              </a:rPr>
+              <a:t>“Phương pháp dạy chẳng hề khô khan.”</a:t>
+            </a:r>
+            <a:endParaRPr lang="en-US" sz="1450" dirty="0"/>
+          </a:p>
+        </p:txBody>
+      </p:sp>
+      <p:sp>
+        <p:nvSpPr>
+          <p:cNvPr id="31" name="Shape 29"/>
+          <p:cNvSpPr/>
+          <p:nvPr/>
+        </p:nvSpPr>
+        <p:spPr>
+          <a:xfrm>
+            <a:off x="8686800" y="3172968"/>
+            <a:ext cx="2834640" cy="384048"/>
+          </a:xfrm>
+          <a:prstGeom prst="roundRect">
+            <a:avLst>
+              <a:gd name="adj" fmla="val 23810"/>
+            </a:avLst>
           </a:prstGeom>
           <a:solidFill>
             <a:srgbClr val="065A82"/>
@@ -6131,14 +6982,14 @@
       </p:sp>
       <p:sp>
         <p:nvSpPr>
-          <p:cNvPr id="10" name="Text 8"/>
-          <p:cNvSpPr/>
-          <p:nvPr/>
-        </p:nvSpPr>
-        <p:spPr>
-          <a:xfrm>
-            <a:off x="640080" y="2770632"/>
-            <a:ext cx="1783080" cy="1463040"/>
+          <p:cNvPr id="32" name="Text 30"/>
+          <p:cNvSpPr/>
+          <p:nvPr/>
+        </p:nvSpPr>
+        <p:spPr>
+          <a:xfrm>
+            <a:off x="8686800" y="3172968"/>
+            <a:ext cx="2834640" cy="384048"/>
           </a:xfrm>
           <a:prstGeom prst="rect">
             <a:avLst/>
@@ -6154,7 +7005,7 @@
               <a:buNone/>
             </a:pPr>
             <a:r>
-              <a:rPr lang="en-US" sz="1500" b="1" dirty="0">
+              <a:rPr lang="en-US" sz="1100" b="1" dirty="0">
                 <a:solidFill>
                   <a:srgbClr val="FFFFFF"/>
                 </a:solidFill>
@@ -6162,111 +7013,652 @@
                 <a:ea typeface="Calibri" pitchFamily="34" charset="-122"/>
                 <a:cs typeface="Calibri" pitchFamily="34" charset="-120"/>
               </a:rPr>
-              <a:t>Concessive</a:t>
-            </a:r>
-            <a:endParaRPr lang="en-US" sz="1500" dirty="0"/>
-          </a:p>
-        </p:txBody>
-      </p:sp>
-      <p:sp>
-        <p:nvSpPr>
-          <p:cNvPr id="11" name="Text 9"/>
-          <p:cNvSpPr/>
-          <p:nvPr/>
-        </p:nvSpPr>
-        <p:spPr>
-          <a:xfrm>
-            <a:off x="2697480" y="2971800"/>
-            <a:ext cx="8686800" cy="457200"/>
-          </a:xfrm>
-          <a:prstGeom prst="rect">
-            <a:avLst/>
-          </a:prstGeom>
-          <a:noFill/>
-          <a:ln/>
-        </p:spPr>
-        <p:txBody>
-          <a:bodyPr wrap="square" lIns="0" tIns="0" rIns="0" bIns="0" rtlCol="0" anchor="ctr"/>
-          <a:lstStyle/>
-          <a:p>
-            <a:pPr indent="0" marL="0">
-              <a:buNone/>
-            </a:pPr>
-            <a:r>
-              <a:rPr lang="en-US" sz="1600" b="1" dirty="0">
-                <a:solidFill>
-                  <a:srgbClr val="21295C"/>
-                </a:solidFill>
-                <a:latin typeface="Calibri" pitchFamily="34" charset="0"/>
-                <a:ea typeface="Calibri" pitchFamily="34" charset="-122"/>
-                <a:cs typeface="Calibri" pitchFamily="34" charset="-120"/>
-              </a:rPr>
-              <a:t>Cộng điểm cả hai vế “tuy…nhưng”</a:t>
-            </a:r>
-            <a:endParaRPr lang="en-US" sz="1600" dirty="0"/>
-          </a:p>
-        </p:txBody>
-      </p:sp>
-      <p:sp>
-        <p:nvSpPr>
-          <p:cNvPr id="12" name="Text 10"/>
-          <p:cNvSpPr/>
-          <p:nvPr/>
-        </p:nvSpPr>
-        <p:spPr>
-          <a:xfrm>
-            <a:off x="2697480" y="3429000"/>
-            <a:ext cx="8732520" cy="685800"/>
-          </a:xfrm>
-          <a:prstGeom prst="rect">
-            <a:avLst/>
-          </a:prstGeom>
-          <a:noFill/>
-          <a:ln/>
-        </p:spPr>
-        <p:txBody>
-          <a:bodyPr wrap="square" lIns="0" tIns="0" rIns="0" bIns="0" rtlCol="0" anchor="ctr"/>
-          <a:lstStyle/>
-          <a:p>
-            <a:pPr indent="0" marL="0">
-              <a:lnSpc>
-                <a:spcPct val="110000"/>
-              </a:lnSpc>
-              <a:buNone/>
-            </a:pPr>
-            <a:r>
-              <a:rPr lang="en-US" sz="1250" dirty="0">
-                <a:solidFill>
-                  <a:srgbClr val="5B6B79"/>
-                </a:solidFill>
-                <a:latin typeface="Calibri" pitchFamily="34" charset="0"/>
-                <a:ea typeface="Calibri" pitchFamily="34" charset="-122"/>
-                <a:cs typeface="Calibri" pitchFamily="34" charset="-120"/>
-              </a:rPr>
-              <a:t>Model cộng dồn cả 2 vế, không nhận ra vế sau “nhưng” mới mang ý chính → điểm tổng lệch hướng.</a:t>
-            </a:r>
-            <a:endParaRPr lang="en-US" sz="1250" dirty="0"/>
-          </a:p>
-        </p:txBody>
-      </p:sp>
-      <p:sp>
-        <p:nvSpPr>
-          <p:cNvPr id="13" name="Shape 11"/>
-          <p:cNvSpPr/>
-          <p:nvPr/>
-        </p:nvSpPr>
-        <p:spPr>
-          <a:xfrm>
-            <a:off x="548640" y="4398264"/>
-            <a:ext cx="11091672" cy="1463040"/>
+              <a:t>Phủ định · Pos → Neg ✗</a:t>
+            </a:r>
+            <a:endParaRPr lang="en-US" sz="1100" dirty="0"/>
+          </a:p>
+        </p:txBody>
+      </p:sp>
+      <p:sp>
+        <p:nvSpPr>
+          <p:cNvPr id="33" name="Shape 31"/>
+          <p:cNvSpPr/>
+          <p:nvPr/>
+        </p:nvSpPr>
+        <p:spPr>
+          <a:xfrm>
+            <a:off x="777240" y="3666744"/>
+            <a:ext cx="1042416" cy="658368"/>
           </a:xfrm>
           <a:prstGeom prst="roundRect">
             <a:avLst>
-              <a:gd name="adj" fmla="val 6250"/>
+              <a:gd name="adj" fmla="val 9722"/>
             </a:avLst>
           </a:prstGeom>
           <a:solidFill>
-            <a:srgbClr val="EAF4F7"/>
+            <a:srgbClr val="EFEFEF"/>
+          </a:solidFill>
+          <a:ln/>
+        </p:spPr>
+      </p:sp>
+      <p:sp>
+        <p:nvSpPr>
+          <p:cNvPr id="34" name="Text 32"/>
+          <p:cNvSpPr/>
+          <p:nvPr/>
+        </p:nvSpPr>
+        <p:spPr>
+          <a:xfrm>
+            <a:off x="777240" y="3712464"/>
+            <a:ext cx="1042416" cy="310896"/>
+          </a:xfrm>
+          <a:prstGeom prst="rect">
+            <a:avLst/>
+          </a:prstGeom>
+          <a:noFill/>
+          <a:ln/>
+        </p:spPr>
+        <p:txBody>
+          <a:bodyPr wrap="square" lIns="0" tIns="0" rIns="0" bIns="0" rtlCol="0" anchor="ctr"/>
+          <a:lstStyle/>
+          <a:p>
+            <a:pPr algn="ctr" indent="0" marL="0">
+              <a:buNone/>
+            </a:pPr>
+            <a:r>
+              <a:rPr lang="en-US" sz="1050" b="1" dirty="0">
+                <a:solidFill>
+                  <a:srgbClr val="21295C"/>
+                </a:solidFill>
+                <a:latin typeface="Calibri" pitchFamily="34" charset="0"/>
+                <a:ea typeface="Calibri" pitchFamily="34" charset="-122"/>
+                <a:cs typeface="Calibri" pitchFamily="34" charset="-120"/>
+              </a:rPr>
+              <a:t>phương pháp</a:t>
+            </a:r>
+            <a:endParaRPr lang="en-US" sz="1050" dirty="0"/>
+          </a:p>
+        </p:txBody>
+      </p:sp>
+      <p:sp>
+        <p:nvSpPr>
+          <p:cNvPr id="35" name="Text 33"/>
+          <p:cNvSpPr/>
+          <p:nvPr/>
+        </p:nvSpPr>
+        <p:spPr>
+          <a:xfrm>
+            <a:off x="777240" y="4005072"/>
+            <a:ext cx="1042416" cy="274320"/>
+          </a:xfrm>
+          <a:prstGeom prst="rect">
+            <a:avLst/>
+          </a:prstGeom>
+          <a:noFill/>
+          <a:ln/>
+        </p:spPr>
+        <p:txBody>
+          <a:bodyPr wrap="square" lIns="0" tIns="0" rIns="0" bIns="0" rtlCol="0" anchor="ctr"/>
+          <a:lstStyle/>
+          <a:p>
+            <a:pPr algn="ctr" indent="0" marL="0">
+              <a:buNone/>
+            </a:pPr>
+            <a:r>
+              <a:rPr lang="en-US" sz="1100" b="1" dirty="0">
+                <a:solidFill>
+                  <a:srgbClr val="5B6B79"/>
+                </a:solidFill>
+                <a:latin typeface="Calibri" pitchFamily="34" charset="0"/>
+                <a:ea typeface="Calibri" pitchFamily="34" charset="-122"/>
+                <a:cs typeface="Calibri" pitchFamily="34" charset="-120"/>
+              </a:rPr>
+              <a:t>—</a:t>
+            </a:r>
+            <a:endParaRPr lang="en-US" sz="1100" dirty="0"/>
+          </a:p>
+        </p:txBody>
+      </p:sp>
+      <p:sp>
+        <p:nvSpPr>
+          <p:cNvPr id="36" name="Shape 34"/>
+          <p:cNvSpPr/>
+          <p:nvPr/>
+        </p:nvSpPr>
+        <p:spPr>
+          <a:xfrm>
+            <a:off x="1911096" y="3666744"/>
+            <a:ext cx="1042416" cy="658368"/>
+          </a:xfrm>
+          <a:prstGeom prst="roundRect">
+            <a:avLst>
+              <a:gd name="adj" fmla="val 9722"/>
+            </a:avLst>
+          </a:prstGeom>
+          <a:solidFill>
+            <a:srgbClr val="E4F3EE"/>
+          </a:solidFill>
+          <a:ln/>
+        </p:spPr>
+      </p:sp>
+      <p:sp>
+        <p:nvSpPr>
+          <p:cNvPr id="37" name="Text 35"/>
+          <p:cNvSpPr/>
+          <p:nvPr/>
+        </p:nvSpPr>
+        <p:spPr>
+          <a:xfrm>
+            <a:off x="1911096" y="3712464"/>
+            <a:ext cx="1042416" cy="310896"/>
+          </a:xfrm>
+          <a:prstGeom prst="rect">
+            <a:avLst/>
+          </a:prstGeom>
+          <a:noFill/>
+          <a:ln/>
+        </p:spPr>
+        <p:txBody>
+          <a:bodyPr wrap="square" lIns="0" tIns="0" rIns="0" bIns="0" rtlCol="0" anchor="ctr"/>
+          <a:lstStyle/>
+          <a:p>
+            <a:pPr algn="ctr" indent="0" marL="0">
+              <a:buNone/>
+            </a:pPr>
+            <a:r>
+              <a:rPr lang="en-US" sz="1050" b="1" dirty="0">
+                <a:solidFill>
+                  <a:srgbClr val="21295C"/>
+                </a:solidFill>
+                <a:latin typeface="Calibri" pitchFamily="34" charset="0"/>
+                <a:ea typeface="Calibri" pitchFamily="34" charset="-122"/>
+                <a:cs typeface="Calibri" pitchFamily="34" charset="-120"/>
+              </a:rPr>
+              <a:t>dạy</a:t>
+            </a:r>
+            <a:endParaRPr lang="en-US" sz="1050" dirty="0"/>
+          </a:p>
+        </p:txBody>
+      </p:sp>
+      <p:sp>
+        <p:nvSpPr>
+          <p:cNvPr id="38" name="Text 36"/>
+          <p:cNvSpPr/>
+          <p:nvPr/>
+        </p:nvSpPr>
+        <p:spPr>
+          <a:xfrm>
+            <a:off x="1911096" y="4005072"/>
+            <a:ext cx="1042416" cy="274320"/>
+          </a:xfrm>
+          <a:prstGeom prst="rect">
+            <a:avLst/>
+          </a:prstGeom>
+          <a:noFill/>
+          <a:ln/>
+        </p:spPr>
+        <p:txBody>
+          <a:bodyPr wrap="square" lIns="0" tIns="0" rIns="0" bIns="0" rtlCol="0" anchor="ctr"/>
+          <a:lstStyle/>
+          <a:p>
+            <a:pPr algn="ctr" indent="0" marL="0">
+              <a:buNone/>
+            </a:pPr>
+            <a:r>
+              <a:rPr lang="en-US" sz="1100" b="1" dirty="0">
+                <a:solidFill>
+                  <a:srgbClr val="3FA796"/>
+                </a:solidFill>
+                <a:latin typeface="Calibri" pitchFamily="34" charset="0"/>
+                <a:ea typeface="Calibri" pitchFamily="34" charset="-122"/>
+                <a:cs typeface="Calibri" pitchFamily="34" charset="-120"/>
+              </a:rPr>
+              <a:t>+1</a:t>
+            </a:r>
+            <a:endParaRPr lang="en-US" sz="1100" dirty="0"/>
+          </a:p>
+        </p:txBody>
+      </p:sp>
+      <p:sp>
+        <p:nvSpPr>
+          <p:cNvPr id="39" name="Shape 37"/>
+          <p:cNvSpPr/>
+          <p:nvPr/>
+        </p:nvSpPr>
+        <p:spPr>
+          <a:xfrm>
+            <a:off x="3044952" y="3666744"/>
+            <a:ext cx="1042416" cy="658368"/>
+          </a:xfrm>
+          <a:prstGeom prst="roundRect">
+            <a:avLst>
+              <a:gd name="adj" fmla="val 9722"/>
+            </a:avLst>
+          </a:prstGeom>
+          <a:solidFill>
+            <a:srgbClr val="E5ECF3"/>
+          </a:solidFill>
+          <a:ln/>
+        </p:spPr>
+      </p:sp>
+      <p:sp>
+        <p:nvSpPr>
+          <p:cNvPr id="40" name="Text 38"/>
+          <p:cNvSpPr/>
+          <p:nvPr/>
+        </p:nvSpPr>
+        <p:spPr>
+          <a:xfrm>
+            <a:off x="3044952" y="3712464"/>
+            <a:ext cx="1042416" cy="310896"/>
+          </a:xfrm>
+          <a:prstGeom prst="rect">
+            <a:avLst/>
+          </a:prstGeom>
+          <a:noFill/>
+          <a:ln/>
+        </p:spPr>
+        <p:txBody>
+          <a:bodyPr wrap="square" lIns="0" tIns="0" rIns="0" bIns="0" rtlCol="0" anchor="ctr"/>
+          <a:lstStyle/>
+          <a:p>
+            <a:pPr algn="ctr" indent="0" marL="0">
+              <a:buNone/>
+            </a:pPr>
+            <a:r>
+              <a:rPr lang="en-US" sz="1050" b="1" dirty="0">
+                <a:solidFill>
+                  <a:srgbClr val="21295C"/>
+                </a:solidFill>
+                <a:latin typeface="Calibri" pitchFamily="34" charset="0"/>
+                <a:ea typeface="Calibri" pitchFamily="34" charset="-122"/>
+                <a:cs typeface="Calibri" pitchFamily="34" charset="-120"/>
+              </a:rPr>
+              <a:t>chẳng</a:t>
+            </a:r>
+            <a:endParaRPr lang="en-US" sz="1050" dirty="0"/>
+          </a:p>
+        </p:txBody>
+      </p:sp>
+      <p:sp>
+        <p:nvSpPr>
+          <p:cNvPr id="41" name="Text 39"/>
+          <p:cNvSpPr/>
+          <p:nvPr/>
+        </p:nvSpPr>
+        <p:spPr>
+          <a:xfrm>
+            <a:off x="3044952" y="4005072"/>
+            <a:ext cx="1042416" cy="274320"/>
+          </a:xfrm>
+          <a:prstGeom prst="rect">
+            <a:avLst/>
+          </a:prstGeom>
+          <a:noFill/>
+          <a:ln/>
+        </p:spPr>
+        <p:txBody>
+          <a:bodyPr wrap="square" lIns="0" tIns="0" rIns="0" bIns="0" rtlCol="0" anchor="ctr"/>
+          <a:lstStyle/>
+          <a:p>
+            <a:pPr algn="ctr" indent="0" marL="0">
+              <a:buNone/>
+            </a:pPr>
+            <a:r>
+              <a:rPr lang="en-US" sz="1100" b="1" dirty="0">
+                <a:solidFill>
+                  <a:srgbClr val="065A82"/>
+                </a:solidFill>
+                <a:latin typeface="Calibri" pitchFamily="34" charset="0"/>
+                <a:ea typeface="Calibri" pitchFamily="34" charset="-122"/>
+                <a:cs typeface="Calibri" pitchFamily="34" charset="-120"/>
+              </a:rPr>
+              <a:t>đảo dấu</a:t>
+            </a:r>
+            <a:endParaRPr lang="en-US" sz="1100" dirty="0"/>
+          </a:p>
+        </p:txBody>
+      </p:sp>
+      <p:sp>
+        <p:nvSpPr>
+          <p:cNvPr id="42" name="Shape 40"/>
+          <p:cNvSpPr/>
+          <p:nvPr/>
+        </p:nvSpPr>
+        <p:spPr>
+          <a:xfrm>
+            <a:off x="4178808" y="3666744"/>
+            <a:ext cx="1042416" cy="658368"/>
+          </a:xfrm>
+          <a:prstGeom prst="roundRect">
+            <a:avLst>
+              <a:gd name="adj" fmla="val 9722"/>
+            </a:avLst>
+          </a:prstGeom>
+          <a:solidFill>
+            <a:srgbClr val="E4F3EE"/>
+          </a:solidFill>
+          <a:ln/>
+        </p:spPr>
+      </p:sp>
+      <p:sp>
+        <p:nvSpPr>
+          <p:cNvPr id="43" name="Text 41"/>
+          <p:cNvSpPr/>
+          <p:nvPr/>
+        </p:nvSpPr>
+        <p:spPr>
+          <a:xfrm>
+            <a:off x="4178808" y="3712464"/>
+            <a:ext cx="1042416" cy="310896"/>
+          </a:xfrm>
+          <a:prstGeom prst="rect">
+            <a:avLst/>
+          </a:prstGeom>
+          <a:noFill/>
+          <a:ln/>
+        </p:spPr>
+        <p:txBody>
+          <a:bodyPr wrap="square" lIns="0" tIns="0" rIns="0" bIns="0" rtlCol="0" anchor="ctr"/>
+          <a:lstStyle/>
+          <a:p>
+            <a:pPr algn="ctr" indent="0" marL="0">
+              <a:buNone/>
+            </a:pPr>
+            <a:r>
+              <a:rPr lang="en-US" sz="1050" b="1" dirty="0">
+                <a:solidFill>
+                  <a:srgbClr val="21295C"/>
+                </a:solidFill>
+                <a:latin typeface="Calibri" pitchFamily="34" charset="0"/>
+                <a:ea typeface="Calibri" pitchFamily="34" charset="-122"/>
+                <a:cs typeface="Calibri" pitchFamily="34" charset="-120"/>
+              </a:rPr>
+              <a:t>hề</a:t>
+            </a:r>
+            <a:endParaRPr lang="en-US" sz="1050" dirty="0"/>
+          </a:p>
+        </p:txBody>
+      </p:sp>
+      <p:sp>
+        <p:nvSpPr>
+          <p:cNvPr id="44" name="Text 42"/>
+          <p:cNvSpPr/>
+          <p:nvPr/>
+        </p:nvSpPr>
+        <p:spPr>
+          <a:xfrm>
+            <a:off x="4178808" y="4005072"/>
+            <a:ext cx="1042416" cy="274320"/>
+          </a:xfrm>
+          <a:prstGeom prst="rect">
+            <a:avLst/>
+          </a:prstGeom>
+          <a:noFill/>
+          <a:ln/>
+        </p:spPr>
+        <p:txBody>
+          <a:bodyPr wrap="square" lIns="0" tIns="0" rIns="0" bIns="0" rtlCol="0" anchor="ctr"/>
+          <a:lstStyle/>
+          <a:p>
+            <a:pPr algn="ctr" indent="0" marL="0">
+              <a:buNone/>
+            </a:pPr>
+            <a:r>
+              <a:rPr lang="en-US" sz="1100" b="1" dirty="0">
+                <a:solidFill>
+                  <a:srgbClr val="3FA796"/>
+                </a:solidFill>
+                <a:latin typeface="Calibri" pitchFamily="34" charset="0"/>
+                <a:ea typeface="Calibri" pitchFamily="34" charset="-122"/>
+                <a:cs typeface="Calibri" pitchFamily="34" charset="-120"/>
+              </a:rPr>
+              <a:t>+1</a:t>
+            </a:r>
+            <a:endParaRPr lang="en-US" sz="1100" dirty="0"/>
+          </a:p>
+        </p:txBody>
+      </p:sp>
+      <p:sp>
+        <p:nvSpPr>
+          <p:cNvPr id="45" name="Shape 43"/>
+          <p:cNvSpPr/>
+          <p:nvPr/>
+        </p:nvSpPr>
+        <p:spPr>
+          <a:xfrm>
+            <a:off x="5312664" y="3666744"/>
+            <a:ext cx="1042416" cy="658368"/>
+          </a:xfrm>
+          <a:prstGeom prst="roundRect">
+            <a:avLst>
+              <a:gd name="adj" fmla="val 9722"/>
+            </a:avLst>
+          </a:prstGeom>
+          <a:solidFill>
+            <a:srgbClr val="FBE9E4"/>
+          </a:solidFill>
+          <a:ln/>
+        </p:spPr>
+      </p:sp>
+      <p:sp>
+        <p:nvSpPr>
+          <p:cNvPr id="46" name="Text 44"/>
+          <p:cNvSpPr/>
+          <p:nvPr/>
+        </p:nvSpPr>
+        <p:spPr>
+          <a:xfrm>
+            <a:off x="5312664" y="3712464"/>
+            <a:ext cx="1042416" cy="310896"/>
+          </a:xfrm>
+          <a:prstGeom prst="rect">
+            <a:avLst/>
+          </a:prstGeom>
+          <a:noFill/>
+          <a:ln/>
+        </p:spPr>
+        <p:txBody>
+          <a:bodyPr wrap="square" lIns="0" tIns="0" rIns="0" bIns="0" rtlCol="0" anchor="ctr"/>
+          <a:lstStyle/>
+          <a:p>
+            <a:pPr algn="ctr" indent="0" marL="0">
+              <a:buNone/>
+            </a:pPr>
+            <a:r>
+              <a:rPr lang="en-US" sz="1050" b="1" dirty="0">
+                <a:solidFill>
+                  <a:srgbClr val="21295C"/>
+                </a:solidFill>
+                <a:latin typeface="Calibri" pitchFamily="34" charset="0"/>
+                <a:ea typeface="Calibri" pitchFamily="34" charset="-122"/>
+                <a:cs typeface="Calibri" pitchFamily="34" charset="-120"/>
+              </a:rPr>
+              <a:t>khô khan</a:t>
+            </a:r>
+            <a:endParaRPr lang="en-US" sz="1050" dirty="0"/>
+          </a:p>
+        </p:txBody>
+      </p:sp>
+      <p:sp>
+        <p:nvSpPr>
+          <p:cNvPr id="47" name="Text 45"/>
+          <p:cNvSpPr/>
+          <p:nvPr/>
+        </p:nvSpPr>
+        <p:spPr>
+          <a:xfrm>
+            <a:off x="5312664" y="4005072"/>
+            <a:ext cx="1042416" cy="274320"/>
+          </a:xfrm>
+          <a:prstGeom prst="rect">
+            <a:avLst/>
+          </a:prstGeom>
+          <a:noFill/>
+          <a:ln/>
+        </p:spPr>
+        <p:txBody>
+          <a:bodyPr wrap="square" lIns="0" tIns="0" rIns="0" bIns="0" rtlCol="0" anchor="ctr"/>
+          <a:lstStyle/>
+          <a:p>
+            <a:pPr algn="ctr" indent="0" marL="0">
+              <a:buNone/>
+            </a:pPr>
+            <a:r>
+              <a:rPr lang="en-US" sz="1100" b="1" dirty="0">
+                <a:solidFill>
+                  <a:srgbClr val="E4572E"/>
+                </a:solidFill>
+                <a:latin typeface="Calibri" pitchFamily="34" charset="0"/>
+                <a:ea typeface="Calibri" pitchFamily="34" charset="-122"/>
+                <a:cs typeface="Calibri" pitchFamily="34" charset="-120"/>
+              </a:rPr>
+              <a:t>−1</a:t>
+            </a:r>
+            <a:endParaRPr lang="en-US" sz="1100" dirty="0"/>
+          </a:p>
+        </p:txBody>
+      </p:sp>
+      <p:sp>
+        <p:nvSpPr>
+          <p:cNvPr id="48" name="Shape 46"/>
+          <p:cNvSpPr/>
+          <p:nvPr/>
+        </p:nvSpPr>
+        <p:spPr>
+          <a:xfrm>
+            <a:off x="6583680" y="3666744"/>
+            <a:ext cx="2286000" cy="658368"/>
+          </a:xfrm>
+          <a:prstGeom prst="roundRect">
+            <a:avLst>
+              <a:gd name="adj" fmla="val 11111"/>
+            </a:avLst>
+          </a:prstGeom>
+          <a:solidFill>
+            <a:srgbClr val="21295C"/>
+          </a:solidFill>
+          <a:ln/>
+        </p:spPr>
+      </p:sp>
+      <p:sp>
+        <p:nvSpPr>
+          <p:cNvPr id="49" name="Text 47"/>
+          <p:cNvSpPr/>
+          <p:nvPr/>
+        </p:nvSpPr>
+        <p:spPr>
+          <a:xfrm>
+            <a:off x="6583680" y="3666744"/>
+            <a:ext cx="2286000" cy="658368"/>
+          </a:xfrm>
+          <a:prstGeom prst="rect">
+            <a:avLst/>
+          </a:prstGeom>
+          <a:noFill/>
+          <a:ln/>
+        </p:spPr>
+        <p:txBody>
+          <a:bodyPr wrap="square" lIns="0" tIns="0" rIns="0" bIns="0" rtlCol="0" anchor="ctr"/>
+          <a:lstStyle/>
+          <a:p>
+            <a:pPr algn="ctr" indent="0" marL="0">
+              <a:buNone/>
+            </a:pPr>
+            <a:r>
+              <a:rPr lang="en-US" sz="1300" b="1" dirty="0">
+                <a:solidFill>
+                  <a:srgbClr val="FFFFFF"/>
+                </a:solidFill>
+              </a:rPr>
+              <a:t>Σ = +1.0  </a:t>
+            </a:r>
+            <a:pPr algn="ctr" indent="0" marL="0">
+              <a:buNone/>
+            </a:pPr>
+            <a:r>
+              <a:rPr lang="en-US" sz="1200" b="1" dirty="0">
+                <a:solidFill>
+                  <a:srgbClr val="E4572E"/>
+                </a:solidFill>
+              </a:rPr>
+              <a:t>→ Negative</a:t>
+            </a:r>
+            <a:endParaRPr lang="en-US" sz="1300" dirty="0"/>
+          </a:p>
+        </p:txBody>
+      </p:sp>
+      <p:sp>
+        <p:nvSpPr>
+          <p:cNvPr id="50" name="Text 48"/>
+          <p:cNvSpPr/>
+          <p:nvPr/>
+        </p:nvSpPr>
+        <p:spPr>
+          <a:xfrm>
+            <a:off x="777240" y="4343400"/>
+            <a:ext cx="10607040" cy="256032"/>
+          </a:xfrm>
+          <a:prstGeom prst="rect">
+            <a:avLst/>
+          </a:prstGeom>
+          <a:noFill/>
+          <a:ln/>
+        </p:spPr>
+        <p:txBody>
+          <a:bodyPr wrap="square" lIns="0" tIns="0" rIns="0" bIns="0" rtlCol="0" anchor="ctr"/>
+          <a:lstStyle/>
+          <a:p>
+            <a:pPr indent="0" marL="0">
+              <a:buNone/>
+            </a:pPr>
+            <a:r>
+              <a:rPr lang="en-US" sz="1150" b="1" dirty="0">
+                <a:solidFill>
+                  <a:srgbClr val="1C7293"/>
+                </a:solidFill>
+                <a:latin typeface="Calibri" pitchFamily="34" charset="0"/>
+                <a:ea typeface="Calibri" pitchFamily="34" charset="-122"/>
+                <a:cs typeface="Calibri" pitchFamily="34" charset="-120"/>
+              </a:rPr>
+              <a:t>Vì sao:  </a:t>
+            </a:r>
+            <a:pPr indent="0" marL="0">
+              <a:buNone/>
+            </a:pPr>
+            <a:r>
+              <a:rPr lang="en-US" sz="1150" dirty="0">
+                <a:solidFill>
+                  <a:srgbClr val="5B6B79"/>
+                </a:solidFill>
+                <a:latin typeface="Calibri" pitchFamily="34" charset="0"/>
+                <a:ea typeface="Calibri" pitchFamily="34" charset="-122"/>
+                <a:cs typeface="Calibri" pitchFamily="34" charset="-120"/>
+              </a:rPr>
+              <a:t>Câu khen (“chẳng hề khô khan”). Đảo dấu chỉ chạm 2 token + từ vựng xếp sai loại → chỉ đạt 1.0 &lt; 2.0.</a:t>
+            </a:r>
+            <a:endParaRPr lang="en-US" sz="1150" dirty="0"/>
+          </a:p>
+        </p:txBody>
+      </p:sp>
+      <p:sp>
+        <p:nvSpPr>
+          <p:cNvPr id="51" name="Shape 49"/>
+          <p:cNvSpPr/>
+          <p:nvPr/>
+        </p:nvSpPr>
+        <p:spPr>
+          <a:xfrm>
+            <a:off x="548640" y="4764024"/>
+            <a:ext cx="11091672" cy="1572768"/>
+          </a:xfrm>
+          <a:prstGeom prst="roundRect">
+            <a:avLst>
+              <a:gd name="adj" fmla="val 5814"/>
+            </a:avLst>
+          </a:prstGeom>
+          <a:solidFill>
+            <a:srgbClr val="F6F9FB"/>
           </a:solidFill>
           <a:ln/>
           <a:effectLst>
@@ -6280,34 +7672,75 @@
       </p:sp>
       <p:sp>
         <p:nvSpPr>
-          <p:cNvPr id="14" name="Shape 12"/>
-          <p:cNvSpPr/>
-          <p:nvPr/>
-        </p:nvSpPr>
-        <p:spPr>
-          <a:xfrm>
-            <a:off x="548640" y="4398264"/>
-            <a:ext cx="1965960" cy="1463040"/>
-          </a:xfrm>
-          <a:prstGeom prst="rect">
-            <a:avLst/>
+          <p:cNvPr id="52" name="Text 50"/>
+          <p:cNvSpPr/>
+          <p:nvPr/>
+        </p:nvSpPr>
+        <p:spPr>
+          <a:xfrm>
+            <a:off x="777240" y="4873752"/>
+            <a:ext cx="7772400" cy="365760"/>
+          </a:xfrm>
+          <a:prstGeom prst="rect">
+            <a:avLst/>
+          </a:prstGeom>
+          <a:noFill/>
+          <a:ln/>
+        </p:spPr>
+        <p:txBody>
+          <a:bodyPr wrap="square" lIns="0" tIns="0" rIns="0" bIns="0" rtlCol="0" anchor="ctr"/>
+          <a:lstStyle/>
+          <a:p>
+            <a:pPr indent="0" marL="0">
+              <a:buNone/>
+            </a:pPr>
+            <a:r>
+              <a:rPr lang="en-US" sz="1450" b="1" dirty="0">
+                <a:solidFill>
+                  <a:srgbClr val="21295C"/>
+                </a:solidFill>
+                <a:latin typeface="Calibri" pitchFamily="34" charset="0"/>
+                <a:ea typeface="Calibri" pitchFamily="34" charset="-122"/>
+                <a:cs typeface="Calibri" pitchFamily="34" charset="-120"/>
+              </a:rPr>
+              <a:t>“Phần lý thuyết hơi nhàm chán.”</a:t>
+            </a:r>
+            <a:endParaRPr lang="en-US" sz="1450" dirty="0"/>
+          </a:p>
+        </p:txBody>
+      </p:sp>
+      <p:sp>
+        <p:nvSpPr>
+          <p:cNvPr id="53" name="Shape 51"/>
+          <p:cNvSpPr/>
+          <p:nvPr/>
+        </p:nvSpPr>
+        <p:spPr>
+          <a:xfrm>
+            <a:off x="8686800" y="4892040"/>
+            <a:ext cx="2834640" cy="384048"/>
+          </a:xfrm>
+          <a:prstGeom prst="roundRect">
+            <a:avLst>
+              <a:gd name="adj" fmla="val 23810"/>
+            </a:avLst>
           </a:prstGeom>
           <a:solidFill>
-            <a:srgbClr val="1C7293"/>
+            <a:srgbClr val="E4572E"/>
           </a:solidFill>
           <a:ln/>
         </p:spPr>
       </p:sp>
       <p:sp>
         <p:nvSpPr>
-          <p:cNvPr id="15" name="Text 13"/>
-          <p:cNvSpPr/>
-          <p:nvPr/>
-        </p:nvSpPr>
-        <p:spPr>
-          <a:xfrm>
-            <a:off x="640080" y="4398264"/>
-            <a:ext cx="1783080" cy="1463040"/>
+          <p:cNvPr id="54" name="Text 52"/>
+          <p:cNvSpPr/>
+          <p:nvPr/>
+        </p:nvSpPr>
+        <p:spPr>
+          <a:xfrm>
+            <a:off x="8686800" y="4892040"/>
+            <a:ext cx="2834640" cy="384048"/>
           </a:xfrm>
           <a:prstGeom prst="rect">
             <a:avLst/>
@@ -6323,7 +7756,7 @@
               <a:buNone/>
             </a:pPr>
             <a:r>
-              <a:rPr lang="en-US" sz="1500" b="1" dirty="0">
+              <a:rPr lang="en-US" sz="1100" b="1" dirty="0">
                 <a:solidFill>
                   <a:srgbClr val="FFFFFF"/>
                 </a:solidFill>
@@ -6331,22 +7764,491 @@
                 <a:ea typeface="Calibri" pitchFamily="34" charset="-122"/>
                 <a:cs typeface="Calibri" pitchFamily="34" charset="-120"/>
               </a:rPr>
-              <a:t>Vocab</a:t>
-            </a:r>
-            <a:endParaRPr lang="en-US" sz="1500" dirty="0"/>
-          </a:p>
-        </p:txBody>
-      </p:sp>
-      <p:sp>
-        <p:nvSpPr>
-          <p:cNvPr id="16" name="Text 14"/>
-          <p:cNvSpPr/>
-          <p:nvPr/>
-        </p:nvSpPr>
-        <p:spPr>
-          <a:xfrm>
-            <a:off x="2697480" y="4599432"/>
-            <a:ext cx="8686800" cy="457200"/>
+              <a:t>Bẫy từ vựng · Neg → Pos ✗</a:t>
+            </a:r>
+            <a:endParaRPr lang="en-US" sz="1100" dirty="0"/>
+          </a:p>
+        </p:txBody>
+      </p:sp>
+      <p:sp>
+        <p:nvSpPr>
+          <p:cNvPr id="55" name="Shape 53"/>
+          <p:cNvSpPr/>
+          <p:nvPr/>
+        </p:nvSpPr>
+        <p:spPr>
+          <a:xfrm>
+            <a:off x="777240" y="5385816"/>
+            <a:ext cx="1042416" cy="658368"/>
+          </a:xfrm>
+          <a:prstGeom prst="roundRect">
+            <a:avLst>
+              <a:gd name="adj" fmla="val 9722"/>
+            </a:avLst>
+          </a:prstGeom>
+          <a:solidFill>
+            <a:srgbClr val="E4F3EE"/>
+          </a:solidFill>
+          <a:ln/>
+        </p:spPr>
+      </p:sp>
+      <p:sp>
+        <p:nvSpPr>
+          <p:cNvPr id="56" name="Text 54"/>
+          <p:cNvSpPr/>
+          <p:nvPr/>
+        </p:nvSpPr>
+        <p:spPr>
+          <a:xfrm>
+            <a:off x="777240" y="5431536"/>
+            <a:ext cx="1042416" cy="310896"/>
+          </a:xfrm>
+          <a:prstGeom prst="rect">
+            <a:avLst/>
+          </a:prstGeom>
+          <a:noFill/>
+          <a:ln/>
+        </p:spPr>
+        <p:txBody>
+          <a:bodyPr wrap="square" lIns="0" tIns="0" rIns="0" bIns="0" rtlCol="0" anchor="ctr"/>
+          <a:lstStyle/>
+          <a:p>
+            <a:pPr algn="ctr" indent="0" marL="0">
+              <a:buNone/>
+            </a:pPr>
+            <a:r>
+              <a:rPr lang="en-US" sz="1050" b="1" dirty="0">
+                <a:solidFill>
+                  <a:srgbClr val="21295C"/>
+                </a:solidFill>
+                <a:latin typeface="Calibri" pitchFamily="34" charset="0"/>
+                <a:ea typeface="Calibri" pitchFamily="34" charset="-122"/>
+                <a:cs typeface="Calibri" pitchFamily="34" charset="-120"/>
+              </a:rPr>
+              <a:t>phần</a:t>
+            </a:r>
+            <a:endParaRPr lang="en-US" sz="1050" dirty="0"/>
+          </a:p>
+        </p:txBody>
+      </p:sp>
+      <p:sp>
+        <p:nvSpPr>
+          <p:cNvPr id="57" name="Text 55"/>
+          <p:cNvSpPr/>
+          <p:nvPr/>
+        </p:nvSpPr>
+        <p:spPr>
+          <a:xfrm>
+            <a:off x="777240" y="5724144"/>
+            <a:ext cx="1042416" cy="274320"/>
+          </a:xfrm>
+          <a:prstGeom prst="rect">
+            <a:avLst/>
+          </a:prstGeom>
+          <a:noFill/>
+          <a:ln/>
+        </p:spPr>
+        <p:txBody>
+          <a:bodyPr wrap="square" lIns="0" tIns="0" rIns="0" bIns="0" rtlCol="0" anchor="ctr"/>
+          <a:lstStyle/>
+          <a:p>
+            <a:pPr algn="ctr" indent="0" marL="0">
+              <a:buNone/>
+            </a:pPr>
+            <a:r>
+              <a:rPr lang="en-US" sz="1100" b="1" dirty="0">
+                <a:solidFill>
+                  <a:srgbClr val="3FA796"/>
+                </a:solidFill>
+                <a:latin typeface="Calibri" pitchFamily="34" charset="0"/>
+                <a:ea typeface="Calibri" pitchFamily="34" charset="-122"/>
+                <a:cs typeface="Calibri" pitchFamily="34" charset="-120"/>
+              </a:rPr>
+              <a:t>+1</a:t>
+            </a:r>
+            <a:endParaRPr lang="en-US" sz="1100" dirty="0"/>
+          </a:p>
+        </p:txBody>
+      </p:sp>
+      <p:sp>
+        <p:nvSpPr>
+          <p:cNvPr id="58" name="Shape 56"/>
+          <p:cNvSpPr/>
+          <p:nvPr/>
+        </p:nvSpPr>
+        <p:spPr>
+          <a:xfrm>
+            <a:off x="1911096" y="5385816"/>
+            <a:ext cx="1042416" cy="658368"/>
+          </a:xfrm>
+          <a:prstGeom prst="roundRect">
+            <a:avLst>
+              <a:gd name="adj" fmla="val 9722"/>
+            </a:avLst>
+          </a:prstGeom>
+          <a:solidFill>
+            <a:srgbClr val="E4F3EE"/>
+          </a:solidFill>
+          <a:ln/>
+        </p:spPr>
+      </p:sp>
+      <p:sp>
+        <p:nvSpPr>
+          <p:cNvPr id="59" name="Text 57"/>
+          <p:cNvSpPr/>
+          <p:nvPr/>
+        </p:nvSpPr>
+        <p:spPr>
+          <a:xfrm>
+            <a:off x="1911096" y="5431536"/>
+            <a:ext cx="1042416" cy="310896"/>
+          </a:xfrm>
+          <a:prstGeom prst="rect">
+            <a:avLst/>
+          </a:prstGeom>
+          <a:noFill/>
+          <a:ln/>
+        </p:spPr>
+        <p:txBody>
+          <a:bodyPr wrap="square" lIns="0" tIns="0" rIns="0" bIns="0" rtlCol="0" anchor="ctr"/>
+          <a:lstStyle/>
+          <a:p>
+            <a:pPr algn="ctr" indent="0" marL="0">
+              <a:buNone/>
+            </a:pPr>
+            <a:r>
+              <a:rPr lang="en-US" sz="1050" b="1" dirty="0">
+                <a:solidFill>
+                  <a:srgbClr val="21295C"/>
+                </a:solidFill>
+                <a:latin typeface="Calibri" pitchFamily="34" charset="0"/>
+                <a:ea typeface="Calibri" pitchFamily="34" charset="-122"/>
+                <a:cs typeface="Calibri" pitchFamily="34" charset="-120"/>
+              </a:rPr>
+              <a:t>lý thuyết</a:t>
+            </a:r>
+            <a:endParaRPr lang="en-US" sz="1050" dirty="0"/>
+          </a:p>
+        </p:txBody>
+      </p:sp>
+      <p:sp>
+        <p:nvSpPr>
+          <p:cNvPr id="60" name="Text 58"/>
+          <p:cNvSpPr/>
+          <p:nvPr/>
+        </p:nvSpPr>
+        <p:spPr>
+          <a:xfrm>
+            <a:off x="1911096" y="5724144"/>
+            <a:ext cx="1042416" cy="274320"/>
+          </a:xfrm>
+          <a:prstGeom prst="rect">
+            <a:avLst/>
+          </a:prstGeom>
+          <a:noFill/>
+          <a:ln/>
+        </p:spPr>
+        <p:txBody>
+          <a:bodyPr wrap="square" lIns="0" tIns="0" rIns="0" bIns="0" rtlCol="0" anchor="ctr"/>
+          <a:lstStyle/>
+          <a:p>
+            <a:pPr algn="ctr" indent="0" marL="0">
+              <a:buNone/>
+            </a:pPr>
+            <a:r>
+              <a:rPr lang="en-US" sz="1100" b="1" dirty="0">
+                <a:solidFill>
+                  <a:srgbClr val="3FA796"/>
+                </a:solidFill>
+                <a:latin typeface="Calibri" pitchFamily="34" charset="0"/>
+                <a:ea typeface="Calibri" pitchFamily="34" charset="-122"/>
+                <a:cs typeface="Calibri" pitchFamily="34" charset="-120"/>
+              </a:rPr>
+              <a:t>+1</a:t>
+            </a:r>
+            <a:endParaRPr lang="en-US" sz="1100" dirty="0"/>
+          </a:p>
+        </p:txBody>
+      </p:sp>
+      <p:sp>
+        <p:nvSpPr>
+          <p:cNvPr id="61" name="Shape 59"/>
+          <p:cNvSpPr/>
+          <p:nvPr/>
+        </p:nvSpPr>
+        <p:spPr>
+          <a:xfrm>
+            <a:off x="3044952" y="5385816"/>
+            <a:ext cx="1042416" cy="658368"/>
+          </a:xfrm>
+          <a:prstGeom prst="roundRect">
+            <a:avLst>
+              <a:gd name="adj" fmla="val 9722"/>
+            </a:avLst>
+          </a:prstGeom>
+          <a:solidFill>
+            <a:srgbClr val="E5ECF3"/>
+          </a:solidFill>
+          <a:ln/>
+        </p:spPr>
+      </p:sp>
+      <p:sp>
+        <p:nvSpPr>
+          <p:cNvPr id="62" name="Text 60"/>
+          <p:cNvSpPr/>
+          <p:nvPr/>
+        </p:nvSpPr>
+        <p:spPr>
+          <a:xfrm>
+            <a:off x="3044952" y="5431536"/>
+            <a:ext cx="1042416" cy="310896"/>
+          </a:xfrm>
+          <a:prstGeom prst="rect">
+            <a:avLst/>
+          </a:prstGeom>
+          <a:noFill/>
+          <a:ln/>
+        </p:spPr>
+        <p:txBody>
+          <a:bodyPr wrap="square" lIns="0" tIns="0" rIns="0" bIns="0" rtlCol="0" anchor="ctr"/>
+          <a:lstStyle/>
+          <a:p>
+            <a:pPr algn="ctr" indent="0" marL="0">
+              <a:buNone/>
+            </a:pPr>
+            <a:r>
+              <a:rPr lang="en-US" sz="1050" b="1" dirty="0">
+                <a:solidFill>
+                  <a:srgbClr val="21295C"/>
+                </a:solidFill>
+                <a:latin typeface="Calibri" pitchFamily="34" charset="0"/>
+                <a:ea typeface="Calibri" pitchFamily="34" charset="-122"/>
+                <a:cs typeface="Calibri" pitchFamily="34" charset="-120"/>
+              </a:rPr>
+              <a:t>hơi</a:t>
+            </a:r>
+            <a:endParaRPr lang="en-US" sz="1050" dirty="0"/>
+          </a:p>
+        </p:txBody>
+      </p:sp>
+      <p:sp>
+        <p:nvSpPr>
+          <p:cNvPr id="63" name="Text 61"/>
+          <p:cNvSpPr/>
+          <p:nvPr/>
+        </p:nvSpPr>
+        <p:spPr>
+          <a:xfrm>
+            <a:off x="3044952" y="5724144"/>
+            <a:ext cx="1042416" cy="274320"/>
+          </a:xfrm>
+          <a:prstGeom prst="rect">
+            <a:avLst/>
+          </a:prstGeom>
+          <a:noFill/>
+          <a:ln/>
+        </p:spPr>
+        <p:txBody>
+          <a:bodyPr wrap="square" lIns="0" tIns="0" rIns="0" bIns="0" rtlCol="0" anchor="ctr"/>
+          <a:lstStyle/>
+          <a:p>
+            <a:pPr algn="ctr" indent="0" marL="0">
+              <a:buNone/>
+            </a:pPr>
+            <a:r>
+              <a:rPr lang="en-US" sz="1100" b="1" dirty="0">
+                <a:solidFill>
+                  <a:srgbClr val="065A82"/>
+                </a:solidFill>
+                <a:latin typeface="Calibri" pitchFamily="34" charset="0"/>
+                <a:ea typeface="Calibri" pitchFamily="34" charset="-122"/>
+                <a:cs typeface="Calibri" pitchFamily="34" charset="-120"/>
+              </a:rPr>
+              <a:t>×0.5</a:t>
+            </a:r>
+            <a:endParaRPr lang="en-US" sz="1100" dirty="0"/>
+          </a:p>
+        </p:txBody>
+      </p:sp>
+      <p:sp>
+        <p:nvSpPr>
+          <p:cNvPr id="64" name="Shape 62"/>
+          <p:cNvSpPr/>
+          <p:nvPr/>
+        </p:nvSpPr>
+        <p:spPr>
+          <a:xfrm>
+            <a:off x="4178808" y="5385816"/>
+            <a:ext cx="1042416" cy="658368"/>
+          </a:xfrm>
+          <a:prstGeom prst="roundRect">
+            <a:avLst>
+              <a:gd name="adj" fmla="val 9722"/>
+            </a:avLst>
+          </a:prstGeom>
+          <a:solidFill>
+            <a:srgbClr val="E4F3EE"/>
+          </a:solidFill>
+          <a:ln/>
+        </p:spPr>
+      </p:sp>
+      <p:sp>
+        <p:nvSpPr>
+          <p:cNvPr id="65" name="Text 63"/>
+          <p:cNvSpPr/>
+          <p:nvPr/>
+        </p:nvSpPr>
+        <p:spPr>
+          <a:xfrm>
+            <a:off x="4178808" y="5431536"/>
+            <a:ext cx="1042416" cy="310896"/>
+          </a:xfrm>
+          <a:prstGeom prst="rect">
+            <a:avLst/>
+          </a:prstGeom>
+          <a:noFill/>
+          <a:ln/>
+        </p:spPr>
+        <p:txBody>
+          <a:bodyPr wrap="square" lIns="0" tIns="0" rIns="0" bIns="0" rtlCol="0" anchor="ctr"/>
+          <a:lstStyle/>
+          <a:p>
+            <a:pPr algn="ctr" indent="0" marL="0">
+              <a:buNone/>
+            </a:pPr>
+            <a:r>
+              <a:rPr lang="en-US" sz="1050" b="1" dirty="0">
+                <a:solidFill>
+                  <a:srgbClr val="21295C"/>
+                </a:solidFill>
+                <a:latin typeface="Calibri" pitchFamily="34" charset="0"/>
+                <a:ea typeface="Calibri" pitchFamily="34" charset="-122"/>
+                <a:cs typeface="Calibri" pitchFamily="34" charset="-120"/>
+              </a:rPr>
+              <a:t>nhàm chán</a:t>
+            </a:r>
+            <a:endParaRPr lang="en-US" sz="1050" dirty="0"/>
+          </a:p>
+        </p:txBody>
+      </p:sp>
+      <p:sp>
+        <p:nvSpPr>
+          <p:cNvPr id="66" name="Text 64"/>
+          <p:cNvSpPr/>
+          <p:nvPr/>
+        </p:nvSpPr>
+        <p:spPr>
+          <a:xfrm>
+            <a:off x="4178808" y="5724144"/>
+            <a:ext cx="1042416" cy="274320"/>
+          </a:xfrm>
+          <a:prstGeom prst="rect">
+            <a:avLst/>
+          </a:prstGeom>
+          <a:noFill/>
+          <a:ln/>
+        </p:spPr>
+        <p:txBody>
+          <a:bodyPr wrap="square" lIns="0" tIns="0" rIns="0" bIns="0" rtlCol="0" anchor="ctr"/>
+          <a:lstStyle/>
+          <a:p>
+            <a:pPr algn="ctr" indent="0" marL="0">
+              <a:buNone/>
+            </a:pPr>
+            <a:r>
+              <a:rPr lang="en-US" sz="1100" b="1" dirty="0">
+                <a:solidFill>
+                  <a:srgbClr val="3FA796"/>
+                </a:solidFill>
+                <a:latin typeface="Calibri" pitchFamily="34" charset="0"/>
+                <a:ea typeface="Calibri" pitchFamily="34" charset="-122"/>
+                <a:cs typeface="Calibri" pitchFamily="34" charset="-120"/>
+              </a:rPr>
+              <a:t>+0.5</a:t>
+            </a:r>
+            <a:endParaRPr lang="en-US" sz="1100" dirty="0"/>
+          </a:p>
+        </p:txBody>
+      </p:sp>
+      <p:sp>
+        <p:nvSpPr>
+          <p:cNvPr id="67" name="Shape 65"/>
+          <p:cNvSpPr/>
+          <p:nvPr/>
+        </p:nvSpPr>
+        <p:spPr>
+          <a:xfrm>
+            <a:off x="5449824" y="5385816"/>
+            <a:ext cx="2286000" cy="658368"/>
+          </a:xfrm>
+          <a:prstGeom prst="roundRect">
+            <a:avLst>
+              <a:gd name="adj" fmla="val 11111"/>
+            </a:avLst>
+          </a:prstGeom>
+          <a:solidFill>
+            <a:srgbClr val="21295C"/>
+          </a:solidFill>
+          <a:ln/>
+        </p:spPr>
+      </p:sp>
+      <p:sp>
+        <p:nvSpPr>
+          <p:cNvPr id="68" name="Text 66"/>
+          <p:cNvSpPr/>
+          <p:nvPr/>
+        </p:nvSpPr>
+        <p:spPr>
+          <a:xfrm>
+            <a:off x="5449824" y="5385816"/>
+            <a:ext cx="2286000" cy="658368"/>
+          </a:xfrm>
+          <a:prstGeom prst="rect">
+            <a:avLst/>
+          </a:prstGeom>
+          <a:noFill/>
+          <a:ln/>
+        </p:spPr>
+        <p:txBody>
+          <a:bodyPr wrap="square" lIns="0" tIns="0" rIns="0" bIns="0" rtlCol="0" anchor="ctr"/>
+          <a:lstStyle/>
+          <a:p>
+            <a:pPr algn="ctr" indent="0" marL="0">
+              <a:buNone/>
+            </a:pPr>
+            <a:r>
+              <a:rPr lang="en-US" sz="1300" b="1" dirty="0">
+                <a:solidFill>
+                  <a:srgbClr val="FFFFFF"/>
+                </a:solidFill>
+              </a:rPr>
+              <a:t>Σ = +2.5  </a:t>
+            </a:r>
+            <a:pPr algn="ctr" indent="0" marL="0">
+              <a:buNone/>
+            </a:pPr>
+            <a:r>
+              <a:rPr lang="en-US" sz="1200" b="1" dirty="0">
+                <a:solidFill>
+                  <a:srgbClr val="E4572E"/>
+                </a:solidFill>
+              </a:rPr>
+              <a:t>→ Positive</a:t>
+            </a:r>
+            <a:endParaRPr lang="en-US" sz="1300" dirty="0"/>
+          </a:p>
+        </p:txBody>
+      </p:sp>
+      <p:sp>
+        <p:nvSpPr>
+          <p:cNvPr id="69" name="Text 67"/>
+          <p:cNvSpPr/>
+          <p:nvPr/>
+        </p:nvSpPr>
+        <p:spPr>
+          <a:xfrm>
+            <a:off x="777240" y="6062472"/>
+            <a:ext cx="10607040" cy="256032"/>
           </a:xfrm>
           <a:prstGeom prst="rect">
             <a:avLst/>
@@ -6362,49 +8264,21 @@
               <a:buNone/>
             </a:pPr>
             <a:r>
-              <a:rPr lang="en-US" sz="1600" b="1" dirty="0">
-                <a:solidFill>
-                  <a:srgbClr val="21295C"/>
-                </a:solidFill>
-                <a:latin typeface="Calibri" pitchFamily="34" charset="0"/>
-                <a:ea typeface="Calibri" pitchFamily="34" charset="-122"/>
-                <a:cs typeface="Calibri" pitchFamily="34" charset="-120"/>
-              </a:rPr>
-              <a:t>Từ trung tính / góp ý chưa có trọng số đúng</a:t>
-            </a:r>
-            <a:endParaRPr lang="en-US" sz="1600" dirty="0"/>
-          </a:p>
-        </p:txBody>
-      </p:sp>
-      <p:sp>
-        <p:nvSpPr>
-          <p:cNvPr id="17" name="Text 15"/>
-          <p:cNvSpPr/>
-          <p:nvPr/>
-        </p:nvSpPr>
-        <p:spPr>
-          <a:xfrm>
-            <a:off x="2697480" y="5056632"/>
-            <a:ext cx="8732520" cy="685800"/>
-          </a:xfrm>
-          <a:prstGeom prst="rect">
-            <a:avLst/>
-          </a:prstGeom>
-          <a:noFill/>
-          <a:ln/>
-        </p:spPr>
-        <p:txBody>
-          <a:bodyPr wrap="square" lIns="0" tIns="0" rIns="0" bIns="0" rtlCol="0" anchor="ctr"/>
-          <a:lstStyle/>
-          <a:p>
+              <a:rPr lang="en-US" sz="1150" b="1" dirty="0">
+                <a:solidFill>
+                  <a:srgbClr val="1C7293"/>
+                </a:solidFill>
+                <a:latin typeface="Calibri" pitchFamily="34" charset="0"/>
+                <a:ea typeface="Calibri" pitchFamily="34" charset="-122"/>
+                <a:cs typeface="Calibri" pitchFamily="34" charset="-120"/>
+              </a:rPr>
+              <a:t>Vì sao:  </a:t>
+            </a:r>
             <a:pPr indent="0" marL="0">
-              <a:lnSpc>
-                <a:spcPct val="110000"/>
-              </a:lnSpc>
-              <a:buNone/>
-            </a:pPr>
-            <a:r>
-              <a:rPr lang="en-US" sz="1250" dirty="0">
+              <a:buNone/>
+            </a:pPr>
+            <a:r>
+              <a:rPr lang="en-US" sz="1150" dirty="0">
                 <a:solidFill>
                   <a:srgbClr val="5B6B79"/>
                 </a:solidFill>
@@ -6412,15 +8286,15 @@
                 <a:ea typeface="Calibri" pitchFamily="34" charset="-122"/>
                 <a:cs typeface="Calibri" pitchFamily="34" charset="-120"/>
               </a:rPr>
-              <a:t>Từ học thuật trung tính lọt vào pos_vocab; câu góp ý (“nên”, “cần”) chưa đủ sức kéo điểm về âm.</a:t>
-            </a:r>
-            <a:endParaRPr lang="en-US" sz="1250" dirty="0"/>
-          </a:p>
-        </p:txBody>
-      </p:sp>
-      <p:sp>
-        <p:nvSpPr>
-          <p:cNvPr id="18" name="Text 16"/>
+              <a:t>“nhàm chán” bị xếp NHẦM vào pos_vocab (+0.5 thay vì âm) — câu chê hoá thành khen.</a:t>
+            </a:r>
+            <a:endParaRPr lang="en-US" sz="1150" dirty="0"/>
+          </a:p>
+        </p:txBody>
+      </p:sp>
+      <p:sp>
+        <p:nvSpPr>
+          <p:cNvPr id="70" name="Text 68"/>
           <p:cNvSpPr/>
           <p:nvPr/>
         </p:nvSpPr>
@@ -6468,6 +8342,623 @@
 <file path=ppt/slides/slide7.xml><?xml version="1.0" encoding="utf-8"?>
 <p:sld xmlns:a="http://schemas.openxmlformats.org/drawingml/2006/main" xmlns:r="http://schemas.openxmlformats.org/officeDocument/2006/relationships" xmlns:p="http://schemas.openxmlformats.org/presentationml/2006/main">
   <p:cSld name="Slide 7">
+    <p:bg>
+      <p:bgPr>
+        <a:solidFill>
+          <a:srgbClr val="FFFFFF"/>
+        </a:solidFill>
+      </p:bgPr>
+    </p:bg>
+    <p:spTree>
+      <p:nvGrpSpPr>
+        <p:cNvPr id="1" name=""/>
+        <p:cNvGrpSpPr/>
+        <p:nvPr/>
+      </p:nvGrpSpPr>
+      <p:grpSpPr>
+        <a:xfrm>
+          <a:off x="0" y="0"/>
+          <a:ext cx="0" cy="0"/>
+          <a:chOff x="0" y="0"/>
+          <a:chExt cx="0" cy="0"/>
+        </a:xfrm>
+      </p:grpSpPr>
+      <p:sp>
+        <p:nvSpPr>
+          <p:cNvPr id="2" name="Text 0"/>
+          <p:cNvSpPr/>
+          <p:nvPr/>
+        </p:nvSpPr>
+        <p:spPr>
+          <a:xfrm>
+            <a:off x="548640" y="365760"/>
+            <a:ext cx="11064240" cy="594360"/>
+          </a:xfrm>
+          <a:prstGeom prst="rect">
+            <a:avLst/>
+          </a:prstGeom>
+          <a:noFill/>
+          <a:ln/>
+        </p:spPr>
+        <p:txBody>
+          <a:bodyPr wrap="square" lIns="0" tIns="0" rIns="0" bIns="0" rtlCol="0" anchor="ctr"/>
+          <a:lstStyle/>
+          <a:p>
+            <a:pPr indent="0" marL="0">
+              <a:buNone/>
+            </a:pPr>
+            <a:r>
+              <a:rPr lang="en-US" sz="3000" b="1" dirty="0">
+                <a:solidFill>
+                  <a:srgbClr val="21295C"/>
+                </a:solidFill>
+                <a:latin typeface="Cambria" pitchFamily="34" charset="0"/>
+                <a:ea typeface="Cambria" pitchFamily="34" charset="-122"/>
+                <a:cs typeface="Cambria" pitchFamily="34" charset="-120"/>
+              </a:rPr>
+              <a:t>Vì sao model sai? 3 nguyên nhân gốc</a:t>
+            </a:r>
+            <a:endParaRPr lang="en-US" sz="3000" dirty="0"/>
+          </a:p>
+        </p:txBody>
+      </p:sp>
+      <p:sp>
+        <p:nvSpPr>
+          <p:cNvPr id="3" name="Shape 1"/>
+          <p:cNvSpPr/>
+          <p:nvPr/>
+        </p:nvSpPr>
+        <p:spPr>
+          <a:xfrm>
+            <a:off x="548640" y="1143000"/>
+            <a:ext cx="11091672" cy="1463040"/>
+          </a:xfrm>
+          <a:prstGeom prst="roundRect">
+            <a:avLst>
+              <a:gd name="adj" fmla="val 6250"/>
+            </a:avLst>
+          </a:prstGeom>
+          <a:solidFill>
+            <a:srgbClr val="EAF4F7"/>
+          </a:solidFill>
+          <a:ln/>
+          <a:effectLst>
+            <a:outerShdw sx="100000" sy="100000" kx="0" ky="0" algn="bl" rotWithShape="0" blurRad="101600" dist="38100" dir="2700000">
+              <a:srgbClr val="000000">
+                <a:alpha val="12000"/>
+              </a:srgbClr>
+            </a:outerShdw>
+          </a:effectLst>
+        </p:spPr>
+      </p:sp>
+      <p:sp>
+        <p:nvSpPr>
+          <p:cNvPr id="4" name="Shape 2"/>
+          <p:cNvSpPr/>
+          <p:nvPr/>
+        </p:nvSpPr>
+        <p:spPr>
+          <a:xfrm>
+            <a:off x="548640" y="1143000"/>
+            <a:ext cx="1965960" cy="1463040"/>
+          </a:xfrm>
+          <a:prstGeom prst="rect">
+            <a:avLst/>
+          </a:prstGeom>
+          <a:solidFill>
+            <a:srgbClr val="E4572E"/>
+          </a:solidFill>
+          <a:ln/>
+        </p:spPr>
+      </p:sp>
+      <p:sp>
+        <p:nvSpPr>
+          <p:cNvPr id="5" name="Text 3"/>
+          <p:cNvSpPr/>
+          <p:nvPr/>
+        </p:nvSpPr>
+        <p:spPr>
+          <a:xfrm>
+            <a:off x="640080" y="1143000"/>
+            <a:ext cx="1783080" cy="1463040"/>
+          </a:xfrm>
+          <a:prstGeom prst="rect">
+            <a:avLst/>
+          </a:prstGeom>
+          <a:noFill/>
+          <a:ln/>
+        </p:spPr>
+        <p:txBody>
+          <a:bodyPr wrap="square" lIns="0" tIns="0" rIns="0" bIns="0" rtlCol="0" anchor="ctr"/>
+          <a:lstStyle/>
+          <a:p>
+            <a:pPr algn="ctr" indent="0" marL="0">
+              <a:buNone/>
+            </a:pPr>
+            <a:r>
+              <a:rPr lang="en-US" sz="1500" b="1" dirty="0">
+                <a:solidFill>
+                  <a:srgbClr val="FFFFFF"/>
+                </a:solidFill>
+                <a:latin typeface="Calibri" pitchFamily="34" charset="0"/>
+                <a:ea typeface="Calibri" pitchFamily="34" charset="-122"/>
+                <a:cs typeface="Calibri" pitchFamily="34" charset="-120"/>
+              </a:rPr>
+              <a:t>Negation</a:t>
+            </a:r>
+            <a:endParaRPr lang="en-US" sz="1500" dirty="0"/>
+          </a:p>
+        </p:txBody>
+      </p:sp>
+      <p:sp>
+        <p:nvSpPr>
+          <p:cNvPr id="6" name="Text 4"/>
+          <p:cNvSpPr/>
+          <p:nvPr/>
+        </p:nvSpPr>
+        <p:spPr>
+          <a:xfrm>
+            <a:off x="2697480" y="1344168"/>
+            <a:ext cx="8686800" cy="457200"/>
+          </a:xfrm>
+          <a:prstGeom prst="rect">
+            <a:avLst/>
+          </a:prstGeom>
+          <a:noFill/>
+          <a:ln/>
+        </p:spPr>
+        <p:txBody>
+          <a:bodyPr wrap="square" lIns="0" tIns="0" rIns="0" bIns="0" rtlCol="0" anchor="ctr"/>
+          <a:lstStyle/>
+          <a:p>
+            <a:pPr indent="0" marL="0">
+              <a:buNone/>
+            </a:pPr>
+            <a:r>
+              <a:rPr lang="en-US" sz="1600" b="1" dirty="0">
+                <a:solidFill>
+                  <a:srgbClr val="21295C"/>
+                </a:solidFill>
+                <a:latin typeface="Calibri" pitchFamily="34" charset="0"/>
+                <a:ea typeface="Calibri" pitchFamily="34" charset="-122"/>
+                <a:cs typeface="Calibri" pitchFamily="34" charset="-120"/>
+              </a:rPr>
+              <a:t>Phủ định chỉ tác dụng trong cửa sổ hẹp</a:t>
+            </a:r>
+            <a:endParaRPr lang="en-US" sz="1600" dirty="0"/>
+          </a:p>
+        </p:txBody>
+      </p:sp>
+      <p:sp>
+        <p:nvSpPr>
+          <p:cNvPr id="7" name="Text 5"/>
+          <p:cNvSpPr/>
+          <p:nvPr/>
+        </p:nvSpPr>
+        <p:spPr>
+          <a:xfrm>
+            <a:off x="2697480" y="1801368"/>
+            <a:ext cx="8732520" cy="685800"/>
+          </a:xfrm>
+          <a:prstGeom prst="rect">
+            <a:avLst/>
+          </a:prstGeom>
+          <a:noFill/>
+          <a:ln/>
+        </p:spPr>
+        <p:txBody>
+          <a:bodyPr wrap="square" lIns="0" tIns="0" rIns="0" bIns="0" rtlCol="0" anchor="ctr"/>
+          <a:lstStyle/>
+          <a:p>
+            <a:pPr indent="0" marL="0">
+              <a:lnSpc>
+                <a:spcPct val="110000"/>
+              </a:lnSpc>
+              <a:buNone/>
+            </a:pPr>
+            <a:r>
+              <a:rPr lang="en-US" sz="1250" dirty="0">
+                <a:solidFill>
+                  <a:srgbClr val="5B6B79"/>
+                </a:solidFill>
+                <a:latin typeface="Calibri" pitchFamily="34" charset="0"/>
+                <a:ea typeface="Calibri" pitchFamily="34" charset="-122"/>
+                <a:cs typeface="Calibri" pitchFamily="34" charset="-120"/>
+              </a:rPr>
+              <a:t>“chưa”, “không” chỉ đảo dấu vài token kế; từ cảm xúc nằm ngoài cửa sổ không bị đảo → câu tiêu cực vẫn dương.</a:t>
+            </a:r>
+            <a:endParaRPr lang="en-US" sz="1250" dirty="0"/>
+          </a:p>
+        </p:txBody>
+      </p:sp>
+      <p:sp>
+        <p:nvSpPr>
+          <p:cNvPr id="8" name="Shape 6"/>
+          <p:cNvSpPr/>
+          <p:nvPr/>
+        </p:nvSpPr>
+        <p:spPr>
+          <a:xfrm>
+            <a:off x="548640" y="2770632"/>
+            <a:ext cx="11091672" cy="1463040"/>
+          </a:xfrm>
+          <a:prstGeom prst="roundRect">
+            <a:avLst>
+              <a:gd name="adj" fmla="val 6250"/>
+            </a:avLst>
+          </a:prstGeom>
+          <a:solidFill>
+            <a:srgbClr val="EAF4F7"/>
+          </a:solidFill>
+          <a:ln/>
+          <a:effectLst>
+            <a:outerShdw sx="100000" sy="100000" kx="0" ky="0" algn="bl" rotWithShape="0" blurRad="101600" dist="38100" dir="2700000">
+              <a:srgbClr val="000000">
+                <a:alpha val="12000"/>
+              </a:srgbClr>
+            </a:outerShdw>
+          </a:effectLst>
+        </p:spPr>
+      </p:sp>
+      <p:sp>
+        <p:nvSpPr>
+          <p:cNvPr id="9" name="Shape 7"/>
+          <p:cNvSpPr/>
+          <p:nvPr/>
+        </p:nvSpPr>
+        <p:spPr>
+          <a:xfrm>
+            <a:off x="548640" y="2770632"/>
+            <a:ext cx="1965960" cy="1463040"/>
+          </a:xfrm>
+          <a:prstGeom prst="rect">
+            <a:avLst/>
+          </a:prstGeom>
+          <a:solidFill>
+            <a:srgbClr val="065A82"/>
+          </a:solidFill>
+          <a:ln/>
+        </p:spPr>
+      </p:sp>
+      <p:sp>
+        <p:nvSpPr>
+          <p:cNvPr id="10" name="Text 8"/>
+          <p:cNvSpPr/>
+          <p:nvPr/>
+        </p:nvSpPr>
+        <p:spPr>
+          <a:xfrm>
+            <a:off x="640080" y="2770632"/>
+            <a:ext cx="1783080" cy="1463040"/>
+          </a:xfrm>
+          <a:prstGeom prst="rect">
+            <a:avLst/>
+          </a:prstGeom>
+          <a:noFill/>
+          <a:ln/>
+        </p:spPr>
+        <p:txBody>
+          <a:bodyPr wrap="square" lIns="0" tIns="0" rIns="0" bIns="0" rtlCol="0" anchor="ctr"/>
+          <a:lstStyle/>
+          <a:p>
+            <a:pPr algn="ctr" indent="0" marL="0">
+              <a:buNone/>
+            </a:pPr>
+            <a:r>
+              <a:rPr lang="en-US" sz="1500" b="1" dirty="0">
+                <a:solidFill>
+                  <a:srgbClr val="FFFFFF"/>
+                </a:solidFill>
+                <a:latin typeface="Calibri" pitchFamily="34" charset="0"/>
+                <a:ea typeface="Calibri" pitchFamily="34" charset="-122"/>
+                <a:cs typeface="Calibri" pitchFamily="34" charset="-120"/>
+              </a:rPr>
+              <a:t>Concessive</a:t>
+            </a:r>
+            <a:endParaRPr lang="en-US" sz="1500" dirty="0"/>
+          </a:p>
+        </p:txBody>
+      </p:sp>
+      <p:sp>
+        <p:nvSpPr>
+          <p:cNvPr id="11" name="Text 9"/>
+          <p:cNvSpPr/>
+          <p:nvPr/>
+        </p:nvSpPr>
+        <p:spPr>
+          <a:xfrm>
+            <a:off x="2697480" y="2971800"/>
+            <a:ext cx="8686800" cy="457200"/>
+          </a:xfrm>
+          <a:prstGeom prst="rect">
+            <a:avLst/>
+          </a:prstGeom>
+          <a:noFill/>
+          <a:ln/>
+        </p:spPr>
+        <p:txBody>
+          <a:bodyPr wrap="square" lIns="0" tIns="0" rIns="0" bIns="0" rtlCol="0" anchor="ctr"/>
+          <a:lstStyle/>
+          <a:p>
+            <a:pPr indent="0" marL="0">
+              <a:buNone/>
+            </a:pPr>
+            <a:r>
+              <a:rPr lang="en-US" sz="1600" b="1" dirty="0">
+                <a:solidFill>
+                  <a:srgbClr val="21295C"/>
+                </a:solidFill>
+                <a:latin typeface="Calibri" pitchFamily="34" charset="0"/>
+                <a:ea typeface="Calibri" pitchFamily="34" charset="-122"/>
+                <a:cs typeface="Calibri" pitchFamily="34" charset="-120"/>
+              </a:rPr>
+              <a:t>Cộng điểm cả hai vế “tuy…nhưng”</a:t>
+            </a:r>
+            <a:endParaRPr lang="en-US" sz="1600" dirty="0"/>
+          </a:p>
+        </p:txBody>
+      </p:sp>
+      <p:sp>
+        <p:nvSpPr>
+          <p:cNvPr id="12" name="Text 10"/>
+          <p:cNvSpPr/>
+          <p:nvPr/>
+        </p:nvSpPr>
+        <p:spPr>
+          <a:xfrm>
+            <a:off x="2697480" y="3429000"/>
+            <a:ext cx="8732520" cy="685800"/>
+          </a:xfrm>
+          <a:prstGeom prst="rect">
+            <a:avLst/>
+          </a:prstGeom>
+          <a:noFill/>
+          <a:ln/>
+        </p:spPr>
+        <p:txBody>
+          <a:bodyPr wrap="square" lIns="0" tIns="0" rIns="0" bIns="0" rtlCol="0" anchor="ctr"/>
+          <a:lstStyle/>
+          <a:p>
+            <a:pPr indent="0" marL="0">
+              <a:lnSpc>
+                <a:spcPct val="110000"/>
+              </a:lnSpc>
+              <a:buNone/>
+            </a:pPr>
+            <a:r>
+              <a:rPr lang="en-US" sz="1250" dirty="0">
+                <a:solidFill>
+                  <a:srgbClr val="5B6B79"/>
+                </a:solidFill>
+                <a:latin typeface="Calibri" pitchFamily="34" charset="0"/>
+                <a:ea typeface="Calibri" pitchFamily="34" charset="-122"/>
+                <a:cs typeface="Calibri" pitchFamily="34" charset="-120"/>
+              </a:rPr>
+              <a:t>Model cộng dồn cả 2 vế, không nhận ra vế sau “nhưng” mới mang ý chính → điểm tổng lệch hướng.</a:t>
+            </a:r>
+            <a:endParaRPr lang="en-US" sz="1250" dirty="0"/>
+          </a:p>
+        </p:txBody>
+      </p:sp>
+      <p:sp>
+        <p:nvSpPr>
+          <p:cNvPr id="13" name="Shape 11"/>
+          <p:cNvSpPr/>
+          <p:nvPr/>
+        </p:nvSpPr>
+        <p:spPr>
+          <a:xfrm>
+            <a:off x="548640" y="4398264"/>
+            <a:ext cx="11091672" cy="1463040"/>
+          </a:xfrm>
+          <a:prstGeom prst="roundRect">
+            <a:avLst>
+              <a:gd name="adj" fmla="val 6250"/>
+            </a:avLst>
+          </a:prstGeom>
+          <a:solidFill>
+            <a:srgbClr val="EAF4F7"/>
+          </a:solidFill>
+          <a:ln/>
+          <a:effectLst>
+            <a:outerShdw sx="100000" sy="100000" kx="0" ky="0" algn="bl" rotWithShape="0" blurRad="101600" dist="38100" dir="2700000">
+              <a:srgbClr val="000000">
+                <a:alpha val="12000"/>
+              </a:srgbClr>
+            </a:outerShdw>
+          </a:effectLst>
+        </p:spPr>
+      </p:sp>
+      <p:sp>
+        <p:nvSpPr>
+          <p:cNvPr id="14" name="Shape 12"/>
+          <p:cNvSpPr/>
+          <p:nvPr/>
+        </p:nvSpPr>
+        <p:spPr>
+          <a:xfrm>
+            <a:off x="548640" y="4398264"/>
+            <a:ext cx="1965960" cy="1463040"/>
+          </a:xfrm>
+          <a:prstGeom prst="rect">
+            <a:avLst/>
+          </a:prstGeom>
+          <a:solidFill>
+            <a:srgbClr val="1C7293"/>
+          </a:solidFill>
+          <a:ln/>
+        </p:spPr>
+      </p:sp>
+      <p:sp>
+        <p:nvSpPr>
+          <p:cNvPr id="15" name="Text 13"/>
+          <p:cNvSpPr/>
+          <p:nvPr/>
+        </p:nvSpPr>
+        <p:spPr>
+          <a:xfrm>
+            <a:off x="640080" y="4398264"/>
+            <a:ext cx="1783080" cy="1463040"/>
+          </a:xfrm>
+          <a:prstGeom prst="rect">
+            <a:avLst/>
+          </a:prstGeom>
+          <a:noFill/>
+          <a:ln/>
+        </p:spPr>
+        <p:txBody>
+          <a:bodyPr wrap="square" lIns="0" tIns="0" rIns="0" bIns="0" rtlCol="0" anchor="ctr"/>
+          <a:lstStyle/>
+          <a:p>
+            <a:pPr algn="ctr" indent="0" marL="0">
+              <a:buNone/>
+            </a:pPr>
+            <a:r>
+              <a:rPr lang="en-US" sz="1500" b="1" dirty="0">
+                <a:solidFill>
+                  <a:srgbClr val="FFFFFF"/>
+                </a:solidFill>
+                <a:latin typeface="Calibri" pitchFamily="34" charset="0"/>
+                <a:ea typeface="Calibri" pitchFamily="34" charset="-122"/>
+                <a:cs typeface="Calibri" pitchFamily="34" charset="-120"/>
+              </a:rPr>
+              <a:t>Vocab</a:t>
+            </a:r>
+            <a:endParaRPr lang="en-US" sz="1500" dirty="0"/>
+          </a:p>
+        </p:txBody>
+      </p:sp>
+      <p:sp>
+        <p:nvSpPr>
+          <p:cNvPr id="16" name="Text 14"/>
+          <p:cNvSpPr/>
+          <p:nvPr/>
+        </p:nvSpPr>
+        <p:spPr>
+          <a:xfrm>
+            <a:off x="2697480" y="4599432"/>
+            <a:ext cx="8686800" cy="457200"/>
+          </a:xfrm>
+          <a:prstGeom prst="rect">
+            <a:avLst/>
+          </a:prstGeom>
+          <a:noFill/>
+          <a:ln/>
+        </p:spPr>
+        <p:txBody>
+          <a:bodyPr wrap="square" lIns="0" tIns="0" rIns="0" bIns="0" rtlCol="0" anchor="ctr"/>
+          <a:lstStyle/>
+          <a:p>
+            <a:pPr indent="0" marL="0">
+              <a:buNone/>
+            </a:pPr>
+            <a:r>
+              <a:rPr lang="en-US" sz="1600" b="1" dirty="0">
+                <a:solidFill>
+                  <a:srgbClr val="21295C"/>
+                </a:solidFill>
+                <a:latin typeface="Calibri" pitchFamily="34" charset="0"/>
+                <a:ea typeface="Calibri" pitchFamily="34" charset="-122"/>
+                <a:cs typeface="Calibri" pitchFamily="34" charset="-120"/>
+              </a:rPr>
+              <a:t>Từ trung tính / góp ý chưa có trọng số đúng</a:t>
+            </a:r>
+            <a:endParaRPr lang="en-US" sz="1600" dirty="0"/>
+          </a:p>
+        </p:txBody>
+      </p:sp>
+      <p:sp>
+        <p:nvSpPr>
+          <p:cNvPr id="17" name="Text 15"/>
+          <p:cNvSpPr/>
+          <p:nvPr/>
+        </p:nvSpPr>
+        <p:spPr>
+          <a:xfrm>
+            <a:off x="2697480" y="5056632"/>
+            <a:ext cx="8732520" cy="685800"/>
+          </a:xfrm>
+          <a:prstGeom prst="rect">
+            <a:avLst/>
+          </a:prstGeom>
+          <a:noFill/>
+          <a:ln/>
+        </p:spPr>
+        <p:txBody>
+          <a:bodyPr wrap="square" lIns="0" tIns="0" rIns="0" bIns="0" rtlCol="0" anchor="ctr"/>
+          <a:lstStyle/>
+          <a:p>
+            <a:pPr indent="0" marL="0">
+              <a:lnSpc>
+                <a:spcPct val="110000"/>
+              </a:lnSpc>
+              <a:buNone/>
+            </a:pPr>
+            <a:r>
+              <a:rPr lang="en-US" sz="1250" dirty="0">
+                <a:solidFill>
+                  <a:srgbClr val="5B6B79"/>
+                </a:solidFill>
+                <a:latin typeface="Calibri" pitchFamily="34" charset="0"/>
+                <a:ea typeface="Calibri" pitchFamily="34" charset="-122"/>
+                <a:cs typeface="Calibri" pitchFamily="34" charset="-120"/>
+              </a:rPr>
+              <a:t>Từ học thuật trung tính lọt vào pos_vocab; câu góp ý (“nên”, “cần”) chưa đủ sức kéo điểm về âm.</a:t>
+            </a:r>
+            <a:endParaRPr lang="en-US" sz="1250" dirty="0"/>
+          </a:p>
+        </p:txBody>
+      </p:sp>
+      <p:sp>
+        <p:nvSpPr>
+          <p:cNvPr id="18" name="Text 16"/>
+          <p:cNvSpPr/>
+          <p:nvPr/>
+        </p:nvSpPr>
+        <p:spPr>
+          <a:xfrm>
+            <a:off x="0" y="6492240"/>
+            <a:ext cx="12188952" cy="274320"/>
+          </a:xfrm>
+          <a:prstGeom prst="rect">
+            <a:avLst/>
+          </a:prstGeom>
+          <a:noFill/>
+          <a:ln/>
+        </p:spPr>
+        <p:txBody>
+          <a:bodyPr wrap="square" lIns="1905" tIns="1905" rIns="1905" bIns="1905" rtlCol="0" anchor="ctr"/>
+          <a:lstStyle/>
+          <a:p>
+            <a:pPr algn="r" indent="0" marL="0">
+              <a:buNone/>
+            </a:pPr>
+            <a:r>
+              <a:rPr lang="en-US" sz="1000" dirty="0">
+                <a:solidFill>
+                  <a:srgbClr val="5B6B79"/>
+                </a:solidFill>
+                <a:latin typeface="Calibri" pitchFamily="34" charset="0"/>
+                <a:ea typeface="Calibri" pitchFamily="34" charset="-122"/>
+                <a:cs typeface="Calibri" pitchFamily="34" charset="-120"/>
+              </a:rPr>
+              <a:t>Task 11 · Error Analysis · run_pipeline.py  |  7</a:t>
+            </a:r>
+            <a:endParaRPr lang="en-US" sz="1000" dirty="0"/>
+          </a:p>
+        </p:txBody>
+      </p:sp>
+    </p:spTree>
+  </p:cSld>
+  <p:clrMapOvr>
+    <a:masterClrMapping/>
+  </p:clrMapOvr>
+</p:sld>
+</file>
+
+<file path=ppt/slides/slide8.xml><?xml version="1.0" encoding="utf-8"?>
+<p:sld xmlns:a="http://schemas.openxmlformats.org/drawingml/2006/main" xmlns:r="http://schemas.openxmlformats.org/officeDocument/2006/relationships" xmlns:p="http://schemas.openxmlformats.org/presentationml/2006/main">
+  <p:cSld name="Slide 8">
     <p:bg>
       <p:bgPr>
         <a:solidFill>
@@ -7258,7 +9749,7 @@
                 <a:ea typeface="Calibri" pitchFamily="34" charset="-122"/>
                 <a:cs typeface="Calibri" pitchFamily="34" charset="-120"/>
               </a:rPr>
-              <a:t>Task 11 · Error Analysis · run_pipeline.py  |  7</a:t>
+              <a:t>Task 11 · Error Analysis · run_pipeline.py  |  8</a:t>
             </a:r>
             <a:endParaRPr lang="en-US" sz="1000" dirty="0"/>
           </a:p>
@@ -7272,9 +9763,9 @@
 </p:sld>
 </file>
 
-<file path=ppt/slides/slide8.xml><?xml version="1.0" encoding="utf-8"?>
+<file path=ppt/slides/slide9.xml><?xml version="1.0" encoding="utf-8"?>
 <p:sld xmlns:a="http://schemas.openxmlformats.org/drawingml/2006/main" xmlns:r="http://schemas.openxmlformats.org/officeDocument/2006/relationships" xmlns:p="http://schemas.openxmlformats.org/presentationml/2006/main">
-  <p:cSld name="Slide 8">
+  <p:cSld name="Slide 9">
     <p:bg>
       <p:bgPr>
         <a:solidFill>
@@ -7630,7 +10121,7 @@
                 <a:ea typeface="Calibri" pitchFamily="34" charset="-122"/>
                 <a:cs typeface="Calibri" pitchFamily="34" charset="-120"/>
               </a:rPr>
-              <a:t>Task 11 · Error Analysis · run_pipeline.py  |  8</a:t>
+              <a:t>Task 11 · Error Analysis · run_pipeline.py  |  9</a:t>
             </a:r>
             <a:endParaRPr lang="en-US" sz="1000" dirty="0"/>
           </a:p>

</xml_diff>